<commit_message>
Added examl prepareation html and mock test suite
</commit_message>
<xml_diff>
--- a/week-4/CCA-F_Module4_Prompt_Engineering_Structured_Output.pptx
+++ b/week-4/CCA-F_Module4_Prompt_Engineering_Structured_Output.pptx
@@ -5,35 +5,35 @@
     <p:sldMasterId id="2147483648" r:id="rId1"/>
   </p:sldMasterIdLst>
   <p:sldIdLst>
-    <p:sldId id="256" r:id="rId7"/>
-    <p:sldId id="257" r:id="rId8"/>
-    <p:sldId id="258" r:id="rId9"/>
-    <p:sldId id="259" r:id="rId10"/>
-    <p:sldId id="260" r:id="rId11"/>
-    <p:sldId id="261" r:id="rId12"/>
-    <p:sldId id="262" r:id="rId13"/>
-    <p:sldId id="263" r:id="rId14"/>
-    <p:sldId id="264" r:id="rId15"/>
-    <p:sldId id="265" r:id="rId16"/>
-    <p:sldId id="266" r:id="rId17"/>
-    <p:sldId id="267" r:id="rId18"/>
-    <p:sldId id="268" r:id="rId19"/>
-    <p:sldId id="269" r:id="rId20"/>
-    <p:sldId id="270" r:id="rId21"/>
-    <p:sldId id="271" r:id="rId22"/>
-    <p:sldId id="272" r:id="rId23"/>
-    <p:sldId id="273" r:id="rId24"/>
-    <p:sldId id="274" r:id="rId25"/>
-    <p:sldId id="275" r:id="rId26"/>
-    <p:sldId id="276" r:id="rId27"/>
-    <p:sldId id="277" r:id="rId28"/>
-    <p:sldId id="278" r:id="rId29"/>
-    <p:sldId id="279" r:id="rId30"/>
-    <p:sldId id="280" r:id="rId31"/>
-    <p:sldId id="281" r:id="rId32"/>
-    <p:sldId id="282" r:id="rId33"/>
+    <p:sldId id="256" r:id="rId2"/>
+    <p:sldId id="257" r:id="rId3"/>
+    <p:sldId id="258" r:id="rId4"/>
+    <p:sldId id="259" r:id="rId5"/>
+    <p:sldId id="260" r:id="rId6"/>
+    <p:sldId id="261" r:id="rId7"/>
+    <p:sldId id="262" r:id="rId8"/>
+    <p:sldId id="263" r:id="rId9"/>
+    <p:sldId id="264" r:id="rId10"/>
+    <p:sldId id="265" r:id="rId11"/>
+    <p:sldId id="266" r:id="rId12"/>
+    <p:sldId id="267" r:id="rId13"/>
+    <p:sldId id="268" r:id="rId14"/>
+    <p:sldId id="269" r:id="rId15"/>
+    <p:sldId id="270" r:id="rId16"/>
+    <p:sldId id="271" r:id="rId17"/>
+    <p:sldId id="272" r:id="rId18"/>
+    <p:sldId id="273" r:id="rId19"/>
+    <p:sldId id="274" r:id="rId20"/>
+    <p:sldId id="275" r:id="rId21"/>
+    <p:sldId id="276" r:id="rId22"/>
+    <p:sldId id="277" r:id="rId23"/>
+    <p:sldId id="278" r:id="rId24"/>
+    <p:sldId id="279" r:id="rId25"/>
+    <p:sldId id="280" r:id="rId26"/>
+    <p:sldId id="281" r:id="rId27"/>
+    <p:sldId id="282" r:id="rId28"/>
   </p:sldIdLst>
-  <p:sldSz cx="12191695" cy="6858000" type="screen4x3"/>
+  <p:sldSz cx="12192000" cy="6858000"/>
   <p:notesSz cx="6858000" cy="9144000"/>
   <p:defaultTextStyle>
     <a:defPPr>
@@ -130,6 +130,22 @@
       </a:defRPr>
     </a:lvl9pPr>
   </p:defaultTextStyle>
+  <p:extLst>
+    <p:ext uri="{EFAFB233-063F-42B5-8137-9DF3F51BA10A}">
+      <p15:sldGuideLst xmlns:p15="http://schemas.microsoft.com/office/powerpoint/2012/main">
+        <p15:guide id="1" orient="horz" pos="2160">
+          <p15:clr>
+            <a:srgbClr val="A4A3A4"/>
+          </p15:clr>
+        </p15:guide>
+        <p15:guide id="2" pos="2880">
+          <p15:clr>
+            <a:srgbClr val="A4A3A4"/>
+          </p15:clr>
+        </p15:guide>
+      </p15:sldGuideLst>
+    </p:ext>
+  </p:extLst>
 </p:presentation>
 </file>
 
@@ -171,10 +187,9 @@
           <a:lstStyle/>
           <a:p>
             <a:r>
-              <a:rPr lang="en-US" smtClean="0"/>
+              <a:rPr lang="en-US"/>
               <a:t>Click to edit Master title style</a:t>
             </a:r>
-            <a:endParaRPr lang="en-US"/>
           </a:p>
         </p:txBody>
       </p:sp>
@@ -290,10 +305,9 @@
           </a:lstStyle>
           <a:p>
             <a:r>
-              <a:rPr lang="en-US" smtClean="0"/>
+              <a:rPr lang="en-US"/>
               <a:t>Click to edit Master subtitle style</a:t>
             </a:r>
-            <a:endParaRPr lang="en-US"/>
           </a:p>
         </p:txBody>
       </p:sp>
@@ -314,7 +328,7 @@
           <a:p>
             <a:fld id="{5BCAD085-E8A6-8845-BD4E-CB4CCA059FC4}" type="datetimeFigureOut">
               <a:rPr lang="en-US" smtClean="0"/>
-              <a:t>1/27/13</a:t>
+              <a:t>7/24/26</a:t>
             </a:fld>
             <a:endParaRPr lang="en-US"/>
           </a:p>
@@ -408,10 +422,9 @@
           <a:lstStyle/>
           <a:p>
             <a:r>
-              <a:rPr lang="en-US" smtClean="0"/>
+              <a:rPr lang="en-US"/>
               <a:t>Click to edit Master title style</a:t>
             </a:r>
-            <a:endParaRPr lang="en-US"/>
           </a:p>
         </p:txBody>
       </p:sp>
@@ -432,38 +445,37 @@
           <a:p>
             <a:pPr lvl="0"/>
             <a:r>
-              <a:rPr lang="en-US" smtClean="0"/>
+              <a:rPr lang="en-US"/>
               <a:t>Click to edit Master text styles</a:t>
             </a:r>
           </a:p>
           <a:p>
             <a:pPr lvl="1"/>
             <a:r>
-              <a:rPr lang="en-US" smtClean="0"/>
+              <a:rPr lang="en-US"/>
               <a:t>Second level</a:t>
             </a:r>
           </a:p>
           <a:p>
             <a:pPr lvl="2"/>
             <a:r>
-              <a:rPr lang="en-US" smtClean="0"/>
+              <a:rPr lang="en-US"/>
               <a:t>Third level</a:t>
             </a:r>
           </a:p>
           <a:p>
             <a:pPr lvl="3"/>
             <a:r>
-              <a:rPr lang="en-US" smtClean="0"/>
+              <a:rPr lang="en-US"/>
               <a:t>Fourth level</a:t>
             </a:r>
           </a:p>
           <a:p>
             <a:pPr lvl="4"/>
             <a:r>
-              <a:rPr lang="en-US" smtClean="0"/>
+              <a:rPr lang="en-US"/>
               <a:t>Fifth level</a:t>
             </a:r>
-            <a:endParaRPr lang="en-US"/>
           </a:p>
         </p:txBody>
       </p:sp>
@@ -484,7 +496,7 @@
           <a:p>
             <a:fld id="{5BCAD085-E8A6-8845-BD4E-CB4CCA059FC4}" type="datetimeFigureOut">
               <a:rPr lang="en-US" smtClean="0"/>
-              <a:t>1/27/13</a:t>
+              <a:t>7/24/26</a:t>
             </a:fld>
             <a:endParaRPr lang="en-US"/>
           </a:p>
@@ -583,10 +595,9 @@
           <a:lstStyle/>
           <a:p>
             <a:r>
-              <a:rPr lang="en-US" smtClean="0"/>
+              <a:rPr lang="en-US"/>
               <a:t>Click to edit Master title style</a:t>
             </a:r>
-            <a:endParaRPr lang="en-US"/>
           </a:p>
         </p:txBody>
       </p:sp>
@@ -612,38 +623,37 @@
           <a:p>
             <a:pPr lvl="0"/>
             <a:r>
-              <a:rPr lang="en-US" smtClean="0"/>
+              <a:rPr lang="en-US"/>
               <a:t>Click to edit Master text styles</a:t>
             </a:r>
           </a:p>
           <a:p>
             <a:pPr lvl="1"/>
             <a:r>
-              <a:rPr lang="en-US" smtClean="0"/>
+              <a:rPr lang="en-US"/>
               <a:t>Second level</a:t>
             </a:r>
           </a:p>
           <a:p>
             <a:pPr lvl="2"/>
             <a:r>
-              <a:rPr lang="en-US" smtClean="0"/>
+              <a:rPr lang="en-US"/>
               <a:t>Third level</a:t>
             </a:r>
           </a:p>
           <a:p>
             <a:pPr lvl="3"/>
             <a:r>
-              <a:rPr lang="en-US" smtClean="0"/>
+              <a:rPr lang="en-US"/>
               <a:t>Fourth level</a:t>
             </a:r>
           </a:p>
           <a:p>
             <a:pPr lvl="4"/>
             <a:r>
-              <a:rPr lang="en-US" smtClean="0"/>
+              <a:rPr lang="en-US"/>
               <a:t>Fifth level</a:t>
             </a:r>
-            <a:endParaRPr lang="en-US"/>
           </a:p>
         </p:txBody>
       </p:sp>
@@ -664,7 +674,7 @@
           <a:p>
             <a:fld id="{5BCAD085-E8A6-8845-BD4E-CB4CCA059FC4}" type="datetimeFigureOut">
               <a:rPr lang="en-US" smtClean="0"/>
-              <a:t>1/27/13</a:t>
+              <a:t>7/24/26</a:t>
             </a:fld>
             <a:endParaRPr lang="en-US"/>
           </a:p>
@@ -758,10 +768,9 @@
           <a:lstStyle/>
           <a:p>
             <a:r>
-              <a:rPr lang="en-US" smtClean="0"/>
+              <a:rPr lang="en-US"/>
               <a:t>Click to edit Master title style</a:t>
             </a:r>
-            <a:endParaRPr lang="en-US"/>
           </a:p>
         </p:txBody>
       </p:sp>
@@ -782,38 +791,37 @@
           <a:p>
             <a:pPr lvl="0"/>
             <a:r>
-              <a:rPr lang="en-US" smtClean="0"/>
+              <a:rPr lang="en-US"/>
               <a:t>Click to edit Master text styles</a:t>
             </a:r>
           </a:p>
           <a:p>
             <a:pPr lvl="1"/>
             <a:r>
-              <a:rPr lang="en-US" smtClean="0"/>
+              <a:rPr lang="en-US"/>
               <a:t>Second level</a:t>
             </a:r>
           </a:p>
           <a:p>
             <a:pPr lvl="2"/>
             <a:r>
-              <a:rPr lang="en-US" smtClean="0"/>
+              <a:rPr lang="en-US"/>
               <a:t>Third level</a:t>
             </a:r>
           </a:p>
           <a:p>
             <a:pPr lvl="3"/>
             <a:r>
-              <a:rPr lang="en-US" smtClean="0"/>
+              <a:rPr lang="en-US"/>
               <a:t>Fourth level</a:t>
             </a:r>
           </a:p>
           <a:p>
             <a:pPr lvl="4"/>
             <a:r>
-              <a:rPr lang="en-US" smtClean="0"/>
+              <a:rPr lang="en-US"/>
               <a:t>Fifth level</a:t>
             </a:r>
-            <a:endParaRPr lang="en-US"/>
           </a:p>
         </p:txBody>
       </p:sp>
@@ -834,7 +842,7 @@
           <a:p>
             <a:fld id="{5BCAD085-E8A6-8845-BD4E-CB4CCA059FC4}" type="datetimeFigureOut">
               <a:rPr lang="en-US" smtClean="0"/>
-              <a:t>1/27/13</a:t>
+              <a:t>7/24/26</a:t>
             </a:fld>
             <a:endParaRPr lang="en-US"/>
           </a:p>
@@ -937,10 +945,9 @@
           </a:lstStyle>
           <a:p>
             <a:r>
-              <a:rPr lang="en-US" smtClean="0"/>
+              <a:rPr lang="en-US"/>
               <a:t>Click to edit Master title style</a:t>
             </a:r>
-            <a:endParaRPr lang="en-US"/>
           </a:p>
         </p:txBody>
       </p:sp>
@@ -1057,7 +1064,7 @@
           <a:p>
             <a:pPr lvl="0"/>
             <a:r>
-              <a:rPr lang="en-US" smtClean="0"/>
+              <a:rPr lang="en-US"/>
               <a:t>Click to edit Master text styles</a:t>
             </a:r>
           </a:p>
@@ -1080,7 +1087,7 @@
           <a:p>
             <a:fld id="{5BCAD085-E8A6-8845-BD4E-CB4CCA059FC4}" type="datetimeFigureOut">
               <a:rPr lang="en-US" smtClean="0"/>
-              <a:t>1/27/13</a:t>
+              <a:t>7/24/26</a:t>
             </a:fld>
             <a:endParaRPr lang="en-US"/>
           </a:p>
@@ -1174,10 +1181,9 @@
           <a:lstStyle/>
           <a:p>
             <a:r>
-              <a:rPr lang="en-US" smtClean="0"/>
+              <a:rPr lang="en-US"/>
               <a:t>Click to edit Master title style</a:t>
             </a:r>
-            <a:endParaRPr lang="en-US"/>
           </a:p>
         </p:txBody>
       </p:sp>
@@ -1231,38 +1237,37 @@
           <a:p>
             <a:pPr lvl="0"/>
             <a:r>
-              <a:rPr lang="en-US" smtClean="0"/>
+              <a:rPr lang="en-US"/>
               <a:t>Click to edit Master text styles</a:t>
             </a:r>
           </a:p>
           <a:p>
             <a:pPr lvl="1"/>
             <a:r>
-              <a:rPr lang="en-US" smtClean="0"/>
+              <a:rPr lang="en-US"/>
               <a:t>Second level</a:t>
             </a:r>
           </a:p>
           <a:p>
             <a:pPr lvl="2"/>
             <a:r>
-              <a:rPr lang="en-US" smtClean="0"/>
+              <a:rPr lang="en-US"/>
               <a:t>Third level</a:t>
             </a:r>
           </a:p>
           <a:p>
             <a:pPr lvl="3"/>
             <a:r>
-              <a:rPr lang="en-US" smtClean="0"/>
+              <a:rPr lang="en-US"/>
               <a:t>Fourth level</a:t>
             </a:r>
           </a:p>
           <a:p>
             <a:pPr lvl="4"/>
             <a:r>
-              <a:rPr lang="en-US" smtClean="0"/>
+              <a:rPr lang="en-US"/>
               <a:t>Fifth level</a:t>
             </a:r>
-            <a:endParaRPr lang="en-US"/>
           </a:p>
         </p:txBody>
       </p:sp>
@@ -1316,38 +1321,37 @@
           <a:p>
             <a:pPr lvl="0"/>
             <a:r>
-              <a:rPr lang="en-US" smtClean="0"/>
+              <a:rPr lang="en-US"/>
               <a:t>Click to edit Master text styles</a:t>
             </a:r>
           </a:p>
           <a:p>
             <a:pPr lvl="1"/>
             <a:r>
-              <a:rPr lang="en-US" smtClean="0"/>
+              <a:rPr lang="en-US"/>
               <a:t>Second level</a:t>
             </a:r>
           </a:p>
           <a:p>
             <a:pPr lvl="2"/>
             <a:r>
-              <a:rPr lang="en-US" smtClean="0"/>
+              <a:rPr lang="en-US"/>
               <a:t>Third level</a:t>
             </a:r>
           </a:p>
           <a:p>
             <a:pPr lvl="3"/>
             <a:r>
-              <a:rPr lang="en-US" smtClean="0"/>
+              <a:rPr lang="en-US"/>
               <a:t>Fourth level</a:t>
             </a:r>
           </a:p>
           <a:p>
             <a:pPr lvl="4"/>
             <a:r>
-              <a:rPr lang="en-US" smtClean="0"/>
+              <a:rPr lang="en-US"/>
               <a:t>Fifth level</a:t>
             </a:r>
-            <a:endParaRPr lang="en-US"/>
           </a:p>
         </p:txBody>
       </p:sp>
@@ -1368,7 +1372,7 @@
           <a:p>
             <a:fld id="{5BCAD085-E8A6-8845-BD4E-CB4CCA059FC4}" type="datetimeFigureOut">
               <a:rPr lang="en-US" smtClean="0"/>
-              <a:t>1/27/13</a:t>
+              <a:t>7/24/26</a:t>
             </a:fld>
             <a:endParaRPr lang="en-US"/>
           </a:p>
@@ -1466,10 +1470,9 @@
           </a:lstStyle>
           <a:p>
             <a:r>
-              <a:rPr lang="en-US" smtClean="0"/>
+              <a:rPr lang="en-US"/>
               <a:t>Click to edit Master title style</a:t>
             </a:r>
-            <a:endParaRPr lang="en-US"/>
           </a:p>
         </p:txBody>
       </p:sp>
@@ -1532,7 +1535,7 @@
           <a:p>
             <a:pPr lvl="0"/>
             <a:r>
-              <a:rPr lang="en-US" smtClean="0"/>
+              <a:rPr lang="en-US"/>
               <a:t>Click to edit Master text styles</a:t>
             </a:r>
           </a:p>
@@ -1588,38 +1591,37 @@
           <a:p>
             <a:pPr lvl="0"/>
             <a:r>
-              <a:rPr lang="en-US" smtClean="0"/>
+              <a:rPr lang="en-US"/>
               <a:t>Click to edit Master text styles</a:t>
             </a:r>
           </a:p>
           <a:p>
             <a:pPr lvl="1"/>
             <a:r>
-              <a:rPr lang="en-US" smtClean="0"/>
+              <a:rPr lang="en-US"/>
               <a:t>Second level</a:t>
             </a:r>
           </a:p>
           <a:p>
             <a:pPr lvl="2"/>
             <a:r>
-              <a:rPr lang="en-US" smtClean="0"/>
+              <a:rPr lang="en-US"/>
               <a:t>Third level</a:t>
             </a:r>
           </a:p>
           <a:p>
             <a:pPr lvl="3"/>
             <a:r>
-              <a:rPr lang="en-US" smtClean="0"/>
+              <a:rPr lang="en-US"/>
               <a:t>Fourth level</a:t>
             </a:r>
           </a:p>
           <a:p>
             <a:pPr lvl="4"/>
             <a:r>
-              <a:rPr lang="en-US" smtClean="0"/>
+              <a:rPr lang="en-US"/>
               <a:t>Fifth level</a:t>
             </a:r>
-            <a:endParaRPr lang="en-US"/>
           </a:p>
         </p:txBody>
       </p:sp>
@@ -1682,7 +1684,7 @@
           <a:p>
             <a:pPr lvl="0"/>
             <a:r>
-              <a:rPr lang="en-US" smtClean="0"/>
+              <a:rPr lang="en-US"/>
               <a:t>Click to edit Master text styles</a:t>
             </a:r>
           </a:p>
@@ -1738,38 +1740,37 @@
           <a:p>
             <a:pPr lvl="0"/>
             <a:r>
-              <a:rPr lang="en-US" smtClean="0"/>
+              <a:rPr lang="en-US"/>
               <a:t>Click to edit Master text styles</a:t>
             </a:r>
           </a:p>
           <a:p>
             <a:pPr lvl="1"/>
             <a:r>
-              <a:rPr lang="en-US" smtClean="0"/>
+              <a:rPr lang="en-US"/>
               <a:t>Second level</a:t>
             </a:r>
           </a:p>
           <a:p>
             <a:pPr lvl="2"/>
             <a:r>
-              <a:rPr lang="en-US" smtClean="0"/>
+              <a:rPr lang="en-US"/>
               <a:t>Third level</a:t>
             </a:r>
           </a:p>
           <a:p>
             <a:pPr lvl="3"/>
             <a:r>
-              <a:rPr lang="en-US" smtClean="0"/>
+              <a:rPr lang="en-US"/>
               <a:t>Fourth level</a:t>
             </a:r>
           </a:p>
           <a:p>
             <a:pPr lvl="4"/>
             <a:r>
-              <a:rPr lang="en-US" smtClean="0"/>
+              <a:rPr lang="en-US"/>
               <a:t>Fifth level</a:t>
             </a:r>
-            <a:endParaRPr lang="en-US"/>
           </a:p>
         </p:txBody>
       </p:sp>
@@ -1790,7 +1791,7 @@
           <a:p>
             <a:fld id="{5BCAD085-E8A6-8845-BD4E-CB4CCA059FC4}" type="datetimeFigureOut">
               <a:rPr lang="en-US" smtClean="0"/>
-              <a:t>1/27/13</a:t>
+              <a:t>7/24/26</a:t>
             </a:fld>
             <a:endParaRPr lang="en-US"/>
           </a:p>
@@ -1884,10 +1885,9 @@
           <a:lstStyle/>
           <a:p>
             <a:r>
-              <a:rPr lang="en-US" smtClean="0"/>
+              <a:rPr lang="en-US"/>
               <a:t>Click to edit Master title style</a:t>
             </a:r>
-            <a:endParaRPr lang="en-US"/>
           </a:p>
         </p:txBody>
       </p:sp>
@@ -1908,7 +1908,7 @@
           <a:p>
             <a:fld id="{5BCAD085-E8A6-8845-BD4E-CB4CCA059FC4}" type="datetimeFigureOut">
               <a:rPr lang="en-US" smtClean="0"/>
-              <a:t>1/27/13</a:t>
+              <a:t>7/24/26</a:t>
             </a:fld>
             <a:endParaRPr lang="en-US"/>
           </a:p>
@@ -2003,7 +2003,7 @@
           <a:p>
             <a:fld id="{5BCAD085-E8A6-8845-BD4E-CB4CCA059FC4}" type="datetimeFigureOut">
               <a:rPr lang="en-US" smtClean="0"/>
-              <a:t>1/27/13</a:t>
+              <a:t>7/24/26</a:t>
             </a:fld>
             <a:endParaRPr lang="en-US"/>
           </a:p>
@@ -2106,10 +2106,9 @@
           </a:lstStyle>
           <a:p>
             <a:r>
-              <a:rPr lang="en-US" smtClean="0"/>
+              <a:rPr lang="en-US"/>
               <a:t>Click to edit Master title style</a:t>
             </a:r>
-            <a:endParaRPr lang="en-US"/>
           </a:p>
         </p:txBody>
       </p:sp>
@@ -2163,38 +2162,37 @@
           <a:p>
             <a:pPr lvl="0"/>
             <a:r>
-              <a:rPr lang="en-US" smtClean="0"/>
+              <a:rPr lang="en-US"/>
               <a:t>Click to edit Master text styles</a:t>
             </a:r>
           </a:p>
           <a:p>
             <a:pPr lvl="1"/>
             <a:r>
-              <a:rPr lang="en-US" smtClean="0"/>
+              <a:rPr lang="en-US"/>
               <a:t>Second level</a:t>
             </a:r>
           </a:p>
           <a:p>
             <a:pPr lvl="2"/>
             <a:r>
-              <a:rPr lang="en-US" smtClean="0"/>
+              <a:rPr lang="en-US"/>
               <a:t>Third level</a:t>
             </a:r>
           </a:p>
           <a:p>
             <a:pPr lvl="3"/>
             <a:r>
-              <a:rPr lang="en-US" smtClean="0"/>
+              <a:rPr lang="en-US"/>
               <a:t>Fourth level</a:t>
             </a:r>
           </a:p>
           <a:p>
             <a:pPr lvl="4"/>
             <a:r>
-              <a:rPr lang="en-US" smtClean="0"/>
+              <a:rPr lang="en-US"/>
               <a:t>Fifth level</a:t>
             </a:r>
-            <a:endParaRPr lang="en-US"/>
           </a:p>
         </p:txBody>
       </p:sp>
@@ -2257,7 +2255,7 @@
           <a:p>
             <a:pPr lvl="0"/>
             <a:r>
-              <a:rPr lang="en-US" smtClean="0"/>
+              <a:rPr lang="en-US"/>
               <a:t>Click to edit Master text styles</a:t>
             </a:r>
           </a:p>
@@ -2280,7 +2278,7 @@
           <a:p>
             <a:fld id="{5BCAD085-E8A6-8845-BD4E-CB4CCA059FC4}" type="datetimeFigureOut">
               <a:rPr lang="en-US" smtClean="0"/>
-              <a:t>1/27/13</a:t>
+              <a:t>7/24/26</a:t>
             </a:fld>
             <a:endParaRPr lang="en-US"/>
           </a:p>
@@ -2383,10 +2381,9 @@
           </a:lstStyle>
           <a:p>
             <a:r>
-              <a:rPr lang="en-US" smtClean="0"/>
+              <a:rPr lang="en-US"/>
               <a:t>Click to edit Master title style</a:t>
             </a:r>
-            <a:endParaRPr lang="en-US"/>
           </a:p>
         </p:txBody>
       </p:sp>
@@ -2510,7 +2507,7 @@
           <a:p>
             <a:pPr lvl="0"/>
             <a:r>
-              <a:rPr lang="en-US" smtClean="0"/>
+              <a:rPr lang="en-US"/>
               <a:t>Click to edit Master text styles</a:t>
             </a:r>
           </a:p>
@@ -2533,7 +2530,7 @@
           <a:p>
             <a:fld id="{5BCAD085-E8A6-8845-BD4E-CB4CCA059FC4}" type="datetimeFigureOut">
               <a:rPr lang="en-US" smtClean="0"/>
-              <a:t>1/27/13</a:t>
+              <a:t>7/24/26</a:t>
             </a:fld>
             <a:endParaRPr lang="en-US"/>
           </a:p>
@@ -2642,10 +2639,9 @@
           <a:lstStyle/>
           <a:p>
             <a:r>
-              <a:rPr lang="en-US" smtClean="0"/>
+              <a:rPr lang="en-US"/>
               <a:t>Click to edit Master title style</a:t>
             </a:r>
-            <a:endParaRPr lang="en-US"/>
           </a:p>
         </p:txBody>
       </p:sp>
@@ -2676,38 +2672,37 @@
           <a:p>
             <a:pPr lvl="0"/>
             <a:r>
-              <a:rPr lang="en-US" smtClean="0"/>
+              <a:rPr lang="en-US"/>
               <a:t>Click to edit Master text styles</a:t>
             </a:r>
           </a:p>
           <a:p>
             <a:pPr lvl="1"/>
             <a:r>
-              <a:rPr lang="en-US" smtClean="0"/>
+              <a:rPr lang="en-US"/>
               <a:t>Second level</a:t>
             </a:r>
           </a:p>
           <a:p>
             <a:pPr lvl="2"/>
             <a:r>
-              <a:rPr lang="en-US" smtClean="0"/>
+              <a:rPr lang="en-US"/>
               <a:t>Third level</a:t>
             </a:r>
           </a:p>
           <a:p>
             <a:pPr lvl="3"/>
             <a:r>
-              <a:rPr lang="en-US" smtClean="0"/>
+              <a:rPr lang="en-US"/>
               <a:t>Fourth level</a:t>
             </a:r>
           </a:p>
           <a:p>
             <a:pPr lvl="4"/>
             <a:r>
-              <a:rPr lang="en-US" smtClean="0"/>
+              <a:rPr lang="en-US"/>
               <a:t>Fifth level</a:t>
             </a:r>
-            <a:endParaRPr lang="en-US"/>
           </a:p>
         </p:txBody>
       </p:sp>
@@ -2746,7 +2741,7 @@
           <a:p>
             <a:fld id="{5BCAD085-E8A6-8845-BD4E-CB4CCA059FC4}" type="datetimeFigureOut">
               <a:rPr lang="en-US" smtClean="0"/>
-              <a:t>1/27/13</a:t>
+              <a:t>7/24/26</a:t>
             </a:fld>
             <a:endParaRPr lang="en-US"/>
           </a:p>
@@ -3105,7 +3100,7 @@
 </file>
 
 <file path=ppt/slides/slide1.xml><?xml version="1.0" encoding="utf-8"?>
-<p:sld xmlns:a="http://schemas.openxmlformats.org/drawingml/2006/main" xmlns:p="http://schemas.openxmlformats.org/presentationml/2006/main" xmlns:r="http://schemas.openxmlformats.org/officeDocument/2006/relationships">
+<p:sld xmlns:a="http://schemas.openxmlformats.org/drawingml/2006/main" xmlns:r="http://schemas.openxmlformats.org/officeDocument/2006/relationships" xmlns:p="http://schemas.openxmlformats.org/presentationml/2006/main">
   <p:cSld>
     <p:bg>
       <p:bgPr>
@@ -3121,7 +3116,14 @@
         <p:cNvGrpSpPr/>
         <p:nvPr/>
       </p:nvGrpSpPr>
-      <p:grpSpPr/>
+      <p:grpSpPr>
+        <a:xfrm>
+          <a:off x="0" y="0"/>
+          <a:ext cx="0" cy="0"/>
+          <a:chOff x="0" y="0"/>
+          <a:chExt cx="0" cy="0"/>
+        </a:xfrm>
+      </p:grpSpPr>
       <p:sp>
         <p:nvSpPr>
           <p:cNvPr id="2" name="TextBox 1"/>
@@ -3234,6 +3236,7 @@
           <a:lstStyle/>
           <a:p>
             <a:pPr algn="ctr"/>
+            <a:endParaRPr/>
           </a:p>
         </p:txBody>
       </p:sp>
@@ -3345,7 +3348,7 @@
           </a:fontRef>
         </p:style>
         <p:txBody>
-          <a:bodyPr rtlCol="0" anchor="ctr" wrap="square"/>
+          <a:bodyPr wrap="square" rtlCol="0" anchor="ctr"/>
           <a:lstStyle/>
           <a:p>
             <a:pPr algn="ctr">
@@ -3402,7 +3405,7 @@
           </a:fontRef>
         </p:style>
         <p:txBody>
-          <a:bodyPr rtlCol="0" anchor="ctr" wrap="square"/>
+          <a:bodyPr wrap="square" rtlCol="0" anchor="ctr"/>
           <a:lstStyle/>
           <a:p>
             <a:pPr algn="ctr">
@@ -3459,7 +3462,7 @@
           </a:fontRef>
         </p:style>
         <p:txBody>
-          <a:bodyPr rtlCol="0" anchor="ctr" wrap="square"/>
+          <a:bodyPr wrap="square" rtlCol="0" anchor="ctr"/>
           <a:lstStyle/>
           <a:p>
             <a:pPr algn="ctr">
@@ -3516,7 +3519,7 @@
           </a:fontRef>
         </p:style>
         <p:txBody>
-          <a:bodyPr rtlCol="0" anchor="ctr" wrap="square"/>
+          <a:bodyPr wrap="square" rtlCol="0" anchor="ctr"/>
           <a:lstStyle/>
           <a:p>
             <a:pPr algn="ctr">
@@ -3573,7 +3576,7 @@
           </a:fontRef>
         </p:style>
         <p:txBody>
-          <a:bodyPr rtlCol="0" anchor="ctr" wrap="square"/>
+          <a:bodyPr wrap="square" rtlCol="0" anchor="ctr"/>
           <a:lstStyle/>
           <a:p>
             <a:pPr algn="ctr">
@@ -3630,7 +3633,7 @@
           </a:fontRef>
         </p:style>
         <p:txBody>
-          <a:bodyPr rtlCol="0" anchor="ctr" wrap="square"/>
+          <a:bodyPr wrap="square" rtlCol="0" anchor="ctr"/>
           <a:lstStyle/>
           <a:p>
             <a:pPr algn="ctr">
@@ -3660,7 +3663,7 @@
 </file>
 
 <file path=ppt/slides/slide10.xml><?xml version="1.0" encoding="utf-8"?>
-<p:sld xmlns:a="http://schemas.openxmlformats.org/drawingml/2006/main" xmlns:p="http://schemas.openxmlformats.org/presentationml/2006/main" xmlns:r="http://schemas.openxmlformats.org/officeDocument/2006/relationships">
+<p:sld xmlns:a="http://schemas.openxmlformats.org/drawingml/2006/main" xmlns:r="http://schemas.openxmlformats.org/officeDocument/2006/relationships" xmlns:p="http://schemas.openxmlformats.org/presentationml/2006/main">
   <p:cSld>
     <p:bg>
       <p:bgPr>
@@ -3676,7 +3679,14 @@
         <p:cNvGrpSpPr/>
         <p:nvPr/>
       </p:nvGrpSpPr>
-      <p:grpSpPr/>
+      <p:grpSpPr>
+        <a:xfrm>
+          <a:off x="0" y="0"/>
+          <a:ext cx="0" cy="0"/>
+          <a:chOff x="0" y="0"/>
+          <a:chExt cx="0" cy="0"/>
+        </a:xfrm>
+      </p:grpSpPr>
       <p:sp>
         <p:nvSpPr>
           <p:cNvPr id="2" name="Rounded Rectangle 1"/>
@@ -3717,6 +3727,7 @@
           <a:lstStyle/>
           <a:p>
             <a:pPr algn="ctr"/>
+            <a:endParaRPr/>
           </a:p>
         </p:txBody>
       </p:sp>
@@ -3870,6 +3881,7 @@
           <a:lstStyle/>
           <a:p>
             <a:pPr algn="ctr"/>
+            <a:endParaRPr/>
           </a:p>
         </p:txBody>
       </p:sp>
@@ -3974,6 +3986,7 @@
                 <a:latin typeface="Calibri"/>
               </a:defRPr>
             </a:pPr>
+            <a:endParaRPr/>
           </a:p>
           <a:p>
             <a:pPr>
@@ -4051,6 +4064,7 @@
                 <a:latin typeface="Calibri"/>
               </a:defRPr>
             </a:pPr>
+            <a:endParaRPr/>
           </a:p>
           <a:p>
             <a:pPr>
@@ -4128,6 +4142,7 @@
           <a:lstStyle/>
           <a:p>
             <a:pPr algn="ctr"/>
+            <a:endParaRPr/>
           </a:p>
         </p:txBody>
       </p:sp>
@@ -4264,6 +4279,7 @@
                 <a:latin typeface="Calibri"/>
               </a:defRPr>
             </a:pPr>
+            <a:endParaRPr/>
           </a:p>
           <a:p>
             <a:pPr>
@@ -4373,6 +4389,7 @@
           <a:lstStyle/>
           <a:p>
             <a:pPr algn="ctr"/>
+            <a:endParaRPr/>
           </a:p>
         </p:txBody>
       </p:sp>
@@ -4477,6 +4494,7 @@
                 <a:latin typeface="Calibri"/>
               </a:defRPr>
             </a:pPr>
+            <a:endParaRPr/>
           </a:p>
           <a:p>
             <a:pPr>
@@ -4538,6 +4556,7 @@
                 <a:latin typeface="Calibri"/>
               </a:defRPr>
             </a:pPr>
+            <a:endParaRPr/>
           </a:p>
           <a:p>
             <a:pPr>
@@ -4615,6 +4634,7 @@
           <a:lstStyle/>
           <a:p>
             <a:pPr algn="ctr"/>
+            <a:endParaRPr/>
           </a:p>
         </p:txBody>
       </p:sp>
@@ -4735,6 +4755,7 @@
                 <a:latin typeface="Calibri"/>
               </a:defRPr>
             </a:pPr>
+            <a:endParaRPr/>
           </a:p>
           <a:p>
             <a:pPr>
@@ -4763,7 +4784,7 @@
 </file>
 
 <file path=ppt/slides/slide11.xml><?xml version="1.0" encoding="utf-8"?>
-<p:sld xmlns:a="http://schemas.openxmlformats.org/drawingml/2006/main" xmlns:p="http://schemas.openxmlformats.org/presentationml/2006/main" xmlns:r="http://schemas.openxmlformats.org/officeDocument/2006/relationships">
+<p:sld xmlns:a="http://schemas.openxmlformats.org/drawingml/2006/main" xmlns:r="http://schemas.openxmlformats.org/officeDocument/2006/relationships" xmlns:p="http://schemas.openxmlformats.org/presentationml/2006/main">
   <p:cSld>
     <p:bg>
       <p:bgPr>
@@ -4779,7 +4800,14 @@
         <p:cNvGrpSpPr/>
         <p:nvPr/>
       </p:nvGrpSpPr>
-      <p:grpSpPr/>
+      <p:grpSpPr>
+        <a:xfrm>
+          <a:off x="0" y="0"/>
+          <a:ext cx="0" cy="0"/>
+          <a:chOff x="0" y="0"/>
+          <a:chExt cx="0" cy="0"/>
+        </a:xfrm>
+      </p:grpSpPr>
       <p:sp>
         <p:nvSpPr>
           <p:cNvPr id="2" name="Oval 1"/>
@@ -4816,7 +4844,7 @@
           </a:fontRef>
         </p:style>
         <p:txBody>
-          <a:bodyPr rtlCol="0" anchor="ctr" wrap="square"/>
+          <a:bodyPr wrap="square" rtlCol="0" anchor="ctr"/>
           <a:lstStyle/>
           <a:p>
             <a:pPr algn="ctr">
@@ -4920,7 +4948,7 @@
 </file>
 
 <file path=ppt/slides/slide12.xml><?xml version="1.0" encoding="utf-8"?>
-<p:sld xmlns:a="http://schemas.openxmlformats.org/drawingml/2006/main" xmlns:p="http://schemas.openxmlformats.org/presentationml/2006/main" xmlns:r="http://schemas.openxmlformats.org/officeDocument/2006/relationships">
+<p:sld xmlns:a="http://schemas.openxmlformats.org/drawingml/2006/main" xmlns:r="http://schemas.openxmlformats.org/officeDocument/2006/relationships" xmlns:p="http://schemas.openxmlformats.org/presentationml/2006/main">
   <p:cSld>
     <p:bg>
       <p:bgPr>
@@ -4936,7 +4964,14 @@
         <p:cNvGrpSpPr/>
         <p:nvPr/>
       </p:nvGrpSpPr>
-      <p:grpSpPr/>
+      <p:grpSpPr>
+        <a:xfrm>
+          <a:off x="0" y="0"/>
+          <a:ext cx="0" cy="0"/>
+          <a:chOff x="0" y="0"/>
+          <a:chExt cx="0" cy="0"/>
+        </a:xfrm>
+      </p:grpSpPr>
       <p:sp>
         <p:nvSpPr>
           <p:cNvPr id="2" name="Rounded Rectangle 1"/>
@@ -4977,6 +5012,7 @@
           <a:lstStyle/>
           <a:p>
             <a:pPr algn="ctr"/>
+            <a:endParaRPr/>
           </a:p>
         </p:txBody>
       </p:sp>
@@ -5094,6 +5130,7 @@
           <a:lstStyle/>
           <a:p>
             <a:pPr algn="ctr"/>
+            <a:endParaRPr/>
           </a:p>
         </p:txBody>
       </p:sp>
@@ -5240,7 +5277,7 @@
           </a:fontRef>
         </p:style>
         <p:txBody>
-          <a:bodyPr rtlCol="0" anchor="ctr" wrap="square"/>
+          <a:bodyPr wrap="square" rtlCol="0" anchor="ctr"/>
           <a:lstStyle/>
           <a:p>
             <a:pPr algn="ctr">
@@ -5341,6 +5378,7 @@
           <a:lstStyle/>
           <a:p>
             <a:pPr algn="ctr"/>
+            <a:endParaRPr/>
           </a:p>
         </p:txBody>
       </p:sp>
@@ -5380,7 +5418,7 @@
           </a:fontRef>
         </p:style>
         <p:txBody>
-          <a:bodyPr rtlCol="0" anchor="ctr" wrap="square"/>
+          <a:bodyPr wrap="square" rtlCol="0" anchor="ctr"/>
           <a:lstStyle/>
           <a:p>
             <a:pPr algn="ctr">
@@ -5481,6 +5519,7 @@
           <a:lstStyle/>
           <a:p>
             <a:pPr algn="ctr"/>
+            <a:endParaRPr/>
           </a:p>
         </p:txBody>
       </p:sp>
@@ -5520,7 +5559,7 @@
           </a:fontRef>
         </p:style>
         <p:txBody>
-          <a:bodyPr rtlCol="0" anchor="ctr" wrap="square"/>
+          <a:bodyPr wrap="square" rtlCol="0" anchor="ctr"/>
           <a:lstStyle/>
           <a:p>
             <a:pPr algn="ctr">
@@ -5621,6 +5660,7 @@
           <a:lstStyle/>
           <a:p>
             <a:pPr algn="ctr"/>
+            <a:endParaRPr/>
           </a:p>
         </p:txBody>
       </p:sp>
@@ -5660,7 +5700,7 @@
           </a:fontRef>
         </p:style>
         <p:txBody>
-          <a:bodyPr rtlCol="0" anchor="ctr" wrap="square"/>
+          <a:bodyPr wrap="square" rtlCol="0" anchor="ctr"/>
           <a:lstStyle/>
           <a:p>
             <a:pPr algn="ctr">
@@ -5763,6 +5803,7 @@
           <a:lstStyle/>
           <a:p>
             <a:pPr algn="ctr"/>
+            <a:endParaRPr/>
           </a:p>
         </p:txBody>
       </p:sp>
@@ -5883,6 +5924,7 @@
                 <a:latin typeface="Courier New"/>
               </a:defRPr>
             </a:pPr>
+            <a:endParaRPr/>
           </a:p>
           <a:p>
             <a:pPr>
@@ -5944,6 +5986,7 @@
           <a:lstStyle/>
           <a:p>
             <a:pPr algn="ctr"/>
+            <a:endParaRPr/>
           </a:p>
         </p:txBody>
       </p:sp>
@@ -6080,6 +6123,7 @@
                 <a:latin typeface="Courier New"/>
               </a:defRPr>
             </a:pPr>
+            <a:endParaRPr/>
           </a:p>
           <a:p>
             <a:pPr>
@@ -6108,7 +6152,7 @@
 </file>
 
 <file path=ppt/slides/slide13.xml><?xml version="1.0" encoding="utf-8"?>
-<p:sld xmlns:a="http://schemas.openxmlformats.org/drawingml/2006/main" xmlns:p="http://schemas.openxmlformats.org/presentationml/2006/main" xmlns:r="http://schemas.openxmlformats.org/officeDocument/2006/relationships">
+<p:sld xmlns:a="http://schemas.openxmlformats.org/drawingml/2006/main" xmlns:r="http://schemas.openxmlformats.org/officeDocument/2006/relationships" xmlns:p="http://schemas.openxmlformats.org/presentationml/2006/main">
   <p:cSld>
     <p:bg>
       <p:bgPr>
@@ -6124,7 +6168,14 @@
         <p:cNvGrpSpPr/>
         <p:nvPr/>
       </p:nvGrpSpPr>
-      <p:grpSpPr/>
+      <p:grpSpPr>
+        <a:xfrm>
+          <a:off x="0" y="0"/>
+          <a:ext cx="0" cy="0"/>
+          <a:chOff x="0" y="0"/>
+          <a:chExt cx="0" cy="0"/>
+        </a:xfrm>
+      </p:grpSpPr>
       <p:sp>
         <p:nvSpPr>
           <p:cNvPr id="2" name="Rounded Rectangle 1"/>
@@ -6165,6 +6216,7 @@
           <a:lstStyle/>
           <a:p>
             <a:pPr algn="ctr"/>
+            <a:endParaRPr/>
           </a:p>
         </p:txBody>
       </p:sp>
@@ -6312,7 +6364,7 @@
           </a:fontRef>
         </p:style>
         <p:txBody>
-          <a:bodyPr rtlCol="0" anchor="ctr" wrap="square"/>
+          <a:bodyPr wrap="square" rtlCol="0" anchor="ctr"/>
           <a:lstStyle/>
           <a:p>
             <a:pPr algn="ctr">
@@ -6411,6 +6463,7 @@
           <a:lstStyle/>
           <a:p>
             <a:pPr algn="ctr"/>
+            <a:endParaRPr/>
           </a:p>
         </p:txBody>
       </p:sp>
@@ -6494,7 +6547,7 @@
           </a:fontRef>
         </p:style>
         <p:txBody>
-          <a:bodyPr rtlCol="0" anchor="ctr" wrap="square"/>
+          <a:bodyPr wrap="square" rtlCol="0" anchor="ctr"/>
           <a:lstStyle/>
           <a:p>
             <a:pPr algn="ctr">
@@ -6547,7 +6600,7 @@
           </a:fontRef>
         </p:style>
         <p:txBody>
-          <a:bodyPr rtlCol="0" anchor="ctr" wrap="square"/>
+          <a:bodyPr wrap="square" rtlCol="0" anchor="ctr"/>
           <a:lstStyle/>
           <a:p>
             <a:pPr algn="ctr">
@@ -6646,6 +6699,7 @@
           <a:lstStyle/>
           <a:p>
             <a:pPr algn="ctr"/>
+            <a:endParaRPr/>
           </a:p>
         </p:txBody>
       </p:sp>
@@ -6729,7 +6783,7 @@
           </a:fontRef>
         </p:style>
         <p:txBody>
-          <a:bodyPr rtlCol="0" anchor="ctr" wrap="square"/>
+          <a:bodyPr wrap="square" rtlCol="0" anchor="ctr"/>
           <a:lstStyle/>
           <a:p>
             <a:pPr algn="ctr">
@@ -6782,7 +6836,7 @@
           </a:fontRef>
         </p:style>
         <p:txBody>
-          <a:bodyPr rtlCol="0" anchor="ctr" wrap="square"/>
+          <a:bodyPr wrap="square" rtlCol="0" anchor="ctr"/>
           <a:lstStyle/>
           <a:p>
             <a:pPr algn="ctr">
@@ -6885,6 +6939,7 @@
           <a:lstStyle/>
           <a:p>
             <a:pPr algn="ctr"/>
+            <a:endParaRPr/>
           </a:p>
         </p:txBody>
       </p:sp>
@@ -6968,7 +7023,7 @@
           </a:fontRef>
         </p:style>
         <p:txBody>
-          <a:bodyPr rtlCol="0" anchor="ctr" wrap="square"/>
+          <a:bodyPr wrap="square" rtlCol="0" anchor="ctr"/>
           <a:lstStyle/>
           <a:p>
             <a:pPr algn="ctr">
@@ -7021,7 +7076,7 @@
           </a:fontRef>
         </p:style>
         <p:txBody>
-          <a:bodyPr rtlCol="0" anchor="ctr" wrap="square"/>
+          <a:bodyPr wrap="square" rtlCol="0" anchor="ctr"/>
           <a:lstStyle/>
           <a:p>
             <a:pPr algn="ctr">
@@ -7120,6 +7175,7 @@
           <a:lstStyle/>
           <a:p>
             <a:pPr algn="ctr"/>
+            <a:endParaRPr/>
           </a:p>
         </p:txBody>
       </p:sp>
@@ -7203,7 +7259,7 @@
           </a:fontRef>
         </p:style>
         <p:txBody>
-          <a:bodyPr rtlCol="0" anchor="ctr" wrap="square"/>
+          <a:bodyPr wrap="square" rtlCol="0" anchor="ctr"/>
           <a:lstStyle/>
           <a:p>
             <a:pPr algn="ctr">
@@ -7262,6 +7318,7 @@
           <a:lstStyle/>
           <a:p>
             <a:pPr algn="ctr"/>
+            <a:endParaRPr/>
           </a:p>
         </p:txBody>
       </p:sp>
@@ -7398,6 +7455,7 @@
                 <a:latin typeface="Calibri"/>
               </a:defRPr>
             </a:pPr>
+            <a:endParaRPr/>
           </a:p>
           <a:p>
             <a:pPr>
@@ -7426,7 +7484,7 @@
 </file>
 
 <file path=ppt/slides/slide14.xml><?xml version="1.0" encoding="utf-8"?>
-<p:sld xmlns:a="http://schemas.openxmlformats.org/drawingml/2006/main" xmlns:p="http://schemas.openxmlformats.org/presentationml/2006/main" xmlns:r="http://schemas.openxmlformats.org/officeDocument/2006/relationships">
+<p:sld xmlns:a="http://schemas.openxmlformats.org/drawingml/2006/main" xmlns:r="http://schemas.openxmlformats.org/officeDocument/2006/relationships" xmlns:p="http://schemas.openxmlformats.org/presentationml/2006/main">
   <p:cSld>
     <p:bg>
       <p:bgPr>
@@ -7442,7 +7500,14 @@
         <p:cNvGrpSpPr/>
         <p:nvPr/>
       </p:nvGrpSpPr>
-      <p:grpSpPr/>
+      <p:grpSpPr>
+        <a:xfrm>
+          <a:off x="0" y="0"/>
+          <a:ext cx="0" cy="0"/>
+          <a:chOff x="0" y="0"/>
+          <a:chExt cx="0" cy="0"/>
+        </a:xfrm>
+      </p:grpSpPr>
       <p:sp>
         <p:nvSpPr>
           <p:cNvPr id="2" name="Rounded Rectangle 1"/>
@@ -7483,6 +7548,7 @@
           <a:lstStyle/>
           <a:p>
             <a:pPr algn="ctr"/>
+            <a:endParaRPr/>
           </a:p>
         </p:txBody>
       </p:sp>
@@ -7634,6 +7700,7 @@
           <a:lstStyle/>
           <a:p>
             <a:pPr algn="ctr"/>
+            <a:endParaRPr/>
           </a:p>
         </p:txBody>
       </p:sp>
@@ -7686,6 +7753,7 @@
                 <a:latin typeface="Courier New"/>
               </a:defRPr>
             </a:pPr>
+            <a:endParaRPr/>
           </a:p>
           <a:p>
             <a:pPr>
@@ -7795,6 +7863,7 @@
                 <a:latin typeface="Courier New"/>
               </a:defRPr>
             </a:pPr>
+            <a:endParaRPr/>
           </a:p>
           <a:p>
             <a:pPr>
@@ -7888,6 +7957,7 @@
                 <a:latin typeface="Courier New"/>
               </a:defRPr>
             </a:pPr>
+            <a:endParaRPr/>
           </a:p>
           <a:p>
             <a:pPr>
@@ -7981,6 +8051,7 @@
                 <a:latin typeface="Courier New"/>
               </a:defRPr>
             </a:pPr>
+            <a:endParaRPr/>
           </a:p>
           <a:p>
             <a:pPr>
@@ -8042,6 +8113,7 @@
                 <a:latin typeface="Courier New"/>
               </a:defRPr>
             </a:pPr>
+            <a:endParaRPr/>
           </a:p>
           <a:p>
             <a:pPr>
@@ -8245,7 +8317,7 @@
           </a:fontRef>
         </p:style>
         <p:txBody>
-          <a:bodyPr rtlCol="0" anchor="ctr" wrap="square"/>
+          <a:bodyPr wrap="square" rtlCol="0" anchor="ctr"/>
           <a:lstStyle/>
           <a:p>
             <a:pPr algn="ctr">
@@ -8346,7 +8418,7 @@
           </a:fontRef>
         </p:style>
         <p:txBody>
-          <a:bodyPr rtlCol="0" anchor="ctr" wrap="square"/>
+          <a:bodyPr wrap="square" rtlCol="0" anchor="ctr"/>
           <a:lstStyle/>
           <a:p>
             <a:pPr algn="ctr">
@@ -8447,7 +8519,7 @@
           </a:fontRef>
         </p:style>
         <p:txBody>
-          <a:bodyPr rtlCol="0" anchor="ctr" wrap="square"/>
+          <a:bodyPr wrap="square" rtlCol="0" anchor="ctr"/>
           <a:lstStyle/>
           <a:p>
             <a:pPr algn="ctr">
@@ -8554,6 +8626,7 @@
           <a:lstStyle/>
           <a:p>
             <a:pPr algn="ctr"/>
+            <a:endParaRPr/>
           </a:p>
         </p:txBody>
       </p:sp>
@@ -8602,7 +8675,7 @@
 </file>
 
 <file path=ppt/slides/slide15.xml><?xml version="1.0" encoding="utf-8"?>
-<p:sld xmlns:a="http://schemas.openxmlformats.org/drawingml/2006/main" xmlns:p="http://schemas.openxmlformats.org/presentationml/2006/main" xmlns:r="http://schemas.openxmlformats.org/officeDocument/2006/relationships">
+<p:sld xmlns:a="http://schemas.openxmlformats.org/drawingml/2006/main" xmlns:r="http://schemas.openxmlformats.org/officeDocument/2006/relationships" xmlns:p="http://schemas.openxmlformats.org/presentationml/2006/main">
   <p:cSld>
     <p:bg>
       <p:bgPr>
@@ -8618,7 +8691,14 @@
         <p:cNvGrpSpPr/>
         <p:nvPr/>
       </p:nvGrpSpPr>
-      <p:grpSpPr/>
+      <p:grpSpPr>
+        <a:xfrm>
+          <a:off x="0" y="0"/>
+          <a:ext cx="0" cy="0"/>
+          <a:chOff x="0" y="0"/>
+          <a:chExt cx="0" cy="0"/>
+        </a:xfrm>
+      </p:grpSpPr>
       <p:sp>
         <p:nvSpPr>
           <p:cNvPr id="2" name="Oval 1"/>
@@ -8655,7 +8735,7 @@
           </a:fontRef>
         </p:style>
         <p:txBody>
-          <a:bodyPr rtlCol="0" anchor="ctr" wrap="square"/>
+          <a:bodyPr wrap="square" rtlCol="0" anchor="ctr"/>
           <a:lstStyle/>
           <a:p>
             <a:pPr algn="ctr">
@@ -8759,7 +8839,7 @@
 </file>
 
 <file path=ppt/slides/slide16.xml><?xml version="1.0" encoding="utf-8"?>
-<p:sld xmlns:a="http://schemas.openxmlformats.org/drawingml/2006/main" xmlns:p="http://schemas.openxmlformats.org/presentationml/2006/main" xmlns:r="http://schemas.openxmlformats.org/officeDocument/2006/relationships">
+<p:sld xmlns:a="http://schemas.openxmlformats.org/drawingml/2006/main" xmlns:r="http://schemas.openxmlformats.org/officeDocument/2006/relationships" xmlns:p="http://schemas.openxmlformats.org/presentationml/2006/main">
   <p:cSld>
     <p:bg>
       <p:bgPr>
@@ -8775,7 +8855,14 @@
         <p:cNvGrpSpPr/>
         <p:nvPr/>
       </p:nvGrpSpPr>
-      <p:grpSpPr/>
+      <p:grpSpPr>
+        <a:xfrm>
+          <a:off x="0" y="0"/>
+          <a:ext cx="0" cy="0"/>
+          <a:chOff x="0" y="0"/>
+          <a:chExt cx="0" cy="0"/>
+        </a:xfrm>
+      </p:grpSpPr>
       <p:sp>
         <p:nvSpPr>
           <p:cNvPr id="2" name="Rounded Rectangle 1"/>
@@ -8816,6 +8903,7 @@
           <a:lstStyle/>
           <a:p>
             <a:pPr algn="ctr"/>
+            <a:endParaRPr/>
           </a:p>
         </p:txBody>
       </p:sp>
@@ -8969,6 +9057,7 @@
           <a:lstStyle/>
           <a:p>
             <a:pPr algn="ctr"/>
+            <a:endParaRPr/>
           </a:p>
         </p:txBody>
       </p:sp>
@@ -9057,6 +9146,7 @@
                 <a:latin typeface="Calibri"/>
               </a:defRPr>
             </a:pPr>
+            <a:endParaRPr/>
           </a:p>
           <a:p>
             <a:pPr>
@@ -9134,6 +9224,7 @@
                 <a:latin typeface="Calibri"/>
               </a:defRPr>
             </a:pPr>
+            <a:endParaRPr/>
           </a:p>
           <a:p>
             <a:pPr>
@@ -9179,6 +9270,7 @@
                 <a:latin typeface="Calibri"/>
               </a:defRPr>
             </a:pPr>
+            <a:endParaRPr/>
           </a:p>
           <a:p>
             <a:pPr>
@@ -9240,6 +9332,7 @@
           <a:lstStyle/>
           <a:p>
             <a:pPr algn="ctr"/>
+            <a:endParaRPr/>
           </a:p>
         </p:txBody>
       </p:sp>
@@ -9328,6 +9421,7 @@
                 <a:latin typeface="Calibri"/>
               </a:defRPr>
             </a:pPr>
+            <a:endParaRPr/>
           </a:p>
           <a:p>
             <a:pPr>
@@ -9405,6 +9499,7 @@
                 <a:latin typeface="Calibri"/>
               </a:defRPr>
             </a:pPr>
+            <a:endParaRPr/>
           </a:p>
           <a:p>
             <a:pPr>
@@ -9450,6 +9545,7 @@
                 <a:latin typeface="Calibri"/>
               </a:defRPr>
             </a:pPr>
+            <a:endParaRPr/>
           </a:p>
           <a:p>
             <a:pPr>
@@ -9511,6 +9607,7 @@
           <a:lstStyle/>
           <a:p>
             <a:pPr algn="ctr"/>
+            <a:endParaRPr/>
           </a:p>
         </p:txBody>
       </p:sp>
@@ -9615,6 +9712,7 @@
                 <a:latin typeface="Calibri"/>
               </a:defRPr>
             </a:pPr>
+            <a:endParaRPr/>
           </a:p>
           <a:p>
             <a:pPr>
@@ -9659,7 +9757,7 @@
 </file>
 
 <file path=ppt/slides/slide17.xml><?xml version="1.0" encoding="utf-8"?>
-<p:sld xmlns:a="http://schemas.openxmlformats.org/drawingml/2006/main" xmlns:p="http://schemas.openxmlformats.org/presentationml/2006/main" xmlns:r="http://schemas.openxmlformats.org/officeDocument/2006/relationships">
+<p:sld xmlns:a="http://schemas.openxmlformats.org/drawingml/2006/main" xmlns:r="http://schemas.openxmlformats.org/officeDocument/2006/relationships" xmlns:p="http://schemas.openxmlformats.org/presentationml/2006/main">
   <p:cSld>
     <p:bg>
       <p:bgPr>
@@ -9675,7 +9773,14 @@
         <p:cNvGrpSpPr/>
         <p:nvPr/>
       </p:nvGrpSpPr>
-      <p:grpSpPr/>
+      <p:grpSpPr>
+        <a:xfrm>
+          <a:off x="0" y="0"/>
+          <a:ext cx="0" cy="0"/>
+          <a:chOff x="0" y="0"/>
+          <a:chExt cx="0" cy="0"/>
+        </a:xfrm>
+      </p:grpSpPr>
       <p:sp>
         <p:nvSpPr>
           <p:cNvPr id="2" name="Rounded Rectangle 1"/>
@@ -9716,6 +9821,7 @@
           <a:lstStyle/>
           <a:p>
             <a:pPr algn="ctr"/>
+            <a:endParaRPr/>
           </a:p>
         </p:txBody>
       </p:sp>
@@ -9863,7 +9969,7 @@
           </a:fontRef>
         </p:style>
         <p:txBody>
-          <a:bodyPr rtlCol="0" anchor="ctr" wrap="square"/>
+          <a:bodyPr wrap="square" rtlCol="0" anchor="ctr"/>
           <a:lstStyle/>
           <a:p>
             <a:pPr algn="ctr">
@@ -9924,6 +10030,7 @@
           <a:lstStyle/>
           <a:p>
             <a:pPr algn="ctr"/>
+            <a:endParaRPr/>
           </a:p>
         </p:txBody>
       </p:sp>
@@ -9963,7 +10070,7 @@
           </a:fontRef>
         </p:style>
         <p:txBody>
-          <a:bodyPr rtlCol="0" anchor="ctr" wrap="square"/>
+          <a:bodyPr wrap="square" rtlCol="0" anchor="ctr"/>
           <a:lstStyle/>
           <a:p>
             <a:pPr algn="ctr">
@@ -10024,6 +10131,7 @@
           <a:lstStyle/>
           <a:p>
             <a:pPr algn="ctr"/>
+            <a:endParaRPr/>
           </a:p>
         </p:txBody>
       </p:sp>
@@ -10063,7 +10171,7 @@
           </a:fontRef>
         </p:style>
         <p:txBody>
-          <a:bodyPr rtlCol="0" anchor="ctr" wrap="square"/>
+          <a:bodyPr wrap="square" rtlCol="0" anchor="ctr"/>
           <a:lstStyle/>
           <a:p>
             <a:pPr algn="ctr">
@@ -10124,6 +10232,7 @@
           <a:lstStyle/>
           <a:p>
             <a:pPr algn="ctr"/>
+            <a:endParaRPr/>
           </a:p>
         </p:txBody>
       </p:sp>
@@ -10163,7 +10272,7 @@
           </a:fontRef>
         </p:style>
         <p:txBody>
-          <a:bodyPr rtlCol="0" anchor="ctr" wrap="square"/>
+          <a:bodyPr wrap="square" rtlCol="0" anchor="ctr"/>
           <a:lstStyle/>
           <a:p>
             <a:pPr algn="ctr">
@@ -10224,6 +10333,7 @@
           <a:lstStyle/>
           <a:p>
             <a:pPr algn="ctr"/>
+            <a:endParaRPr/>
           </a:p>
         </p:txBody>
       </p:sp>
@@ -10263,7 +10373,7 @@
           </a:fontRef>
         </p:style>
         <p:txBody>
-          <a:bodyPr rtlCol="0" anchor="ctr" wrap="square"/>
+          <a:bodyPr wrap="square" rtlCol="0" anchor="ctr"/>
           <a:lstStyle/>
           <a:p>
             <a:pPr algn="ctr">
@@ -10360,6 +10470,7 @@
           <a:lstStyle/>
           <a:p>
             <a:pPr algn="ctr"/>
+            <a:endParaRPr/>
           </a:p>
         </p:txBody>
       </p:sp>
@@ -10412,6 +10523,7 @@
                 <a:latin typeface="Courier New"/>
               </a:defRPr>
             </a:pPr>
+            <a:endParaRPr/>
           </a:p>
           <a:p>
             <a:pPr>
@@ -10473,6 +10585,7 @@
                 <a:latin typeface="Courier New"/>
               </a:defRPr>
             </a:pPr>
+            <a:endParaRPr/>
           </a:p>
           <a:p>
             <a:pPr>
@@ -10534,6 +10647,7 @@
                 <a:latin typeface="Courier New"/>
               </a:defRPr>
             </a:pPr>
+            <a:endParaRPr/>
           </a:p>
           <a:p>
             <a:pPr>
@@ -10753,7 +10867,7 @@
           </a:fontRef>
         </p:style>
         <p:txBody>
-          <a:bodyPr rtlCol="0" anchor="ctr" wrap="square"/>
+          <a:bodyPr wrap="square" rtlCol="0" anchor="ctr"/>
           <a:lstStyle/>
           <a:p>
             <a:pPr algn="ctr">
@@ -10850,7 +10964,7 @@
           </a:fontRef>
         </p:style>
         <p:txBody>
-          <a:bodyPr rtlCol="0" anchor="ctr" wrap="square"/>
+          <a:bodyPr wrap="square" rtlCol="0" anchor="ctr"/>
           <a:lstStyle/>
           <a:p>
             <a:pPr algn="ctr">
@@ -10947,7 +11061,7 @@
           </a:fontRef>
         </p:style>
         <p:txBody>
-          <a:bodyPr rtlCol="0" anchor="ctr" wrap="square"/>
+          <a:bodyPr wrap="square" rtlCol="0" anchor="ctr"/>
           <a:lstStyle/>
           <a:p>
             <a:pPr algn="ctr">
@@ -11021,7 +11135,7 @@
 </file>
 
 <file path=ppt/slides/slide18.xml><?xml version="1.0" encoding="utf-8"?>
-<p:sld xmlns:a="http://schemas.openxmlformats.org/drawingml/2006/main" xmlns:p="http://schemas.openxmlformats.org/presentationml/2006/main" xmlns:r="http://schemas.openxmlformats.org/officeDocument/2006/relationships">
+<p:sld xmlns:a="http://schemas.openxmlformats.org/drawingml/2006/main" xmlns:r="http://schemas.openxmlformats.org/officeDocument/2006/relationships" xmlns:p="http://schemas.openxmlformats.org/presentationml/2006/main">
   <p:cSld>
     <p:bg>
       <p:bgPr>
@@ -11037,7 +11151,14 @@
         <p:cNvGrpSpPr/>
         <p:nvPr/>
       </p:nvGrpSpPr>
-      <p:grpSpPr/>
+      <p:grpSpPr>
+        <a:xfrm>
+          <a:off x="0" y="0"/>
+          <a:ext cx="0" cy="0"/>
+          <a:chOff x="0" y="0"/>
+          <a:chExt cx="0" cy="0"/>
+        </a:xfrm>
+      </p:grpSpPr>
       <p:sp>
         <p:nvSpPr>
           <p:cNvPr id="2" name="Rounded Rectangle 1"/>
@@ -11078,6 +11199,7 @@
           <a:lstStyle/>
           <a:p>
             <a:pPr algn="ctr"/>
+            <a:endParaRPr/>
           </a:p>
         </p:txBody>
       </p:sp>
@@ -11195,6 +11317,7 @@
           <a:lstStyle/>
           <a:p>
             <a:pPr algn="ctr"/>
+            <a:endParaRPr/>
           </a:p>
         </p:txBody>
       </p:sp>
@@ -11267,6 +11390,7 @@
                 <a:latin typeface="Calibri"/>
               </a:defRPr>
             </a:pPr>
+            <a:endParaRPr/>
           </a:p>
           <a:p>
             <a:pPr>
@@ -11344,6 +11468,7 @@
                 <a:latin typeface="Calibri"/>
               </a:defRPr>
             </a:pPr>
+            <a:endParaRPr/>
           </a:p>
           <a:p>
             <a:pPr>
@@ -11421,6 +11546,7 @@
                 <a:latin typeface="Calibri"/>
               </a:defRPr>
             </a:pPr>
+            <a:endParaRPr/>
           </a:p>
           <a:p>
             <a:pPr>
@@ -11482,6 +11608,7 @@
                 <a:latin typeface="Calibri"/>
               </a:defRPr>
             </a:pPr>
+            <a:endParaRPr/>
           </a:p>
           <a:p>
             <a:pPr>
@@ -11526,7 +11653,7 @@
 </file>
 
 <file path=ppt/slides/slide19.xml><?xml version="1.0" encoding="utf-8"?>
-<p:sld xmlns:a="http://schemas.openxmlformats.org/drawingml/2006/main" xmlns:p="http://schemas.openxmlformats.org/presentationml/2006/main" xmlns:r="http://schemas.openxmlformats.org/officeDocument/2006/relationships">
+<p:sld xmlns:a="http://schemas.openxmlformats.org/drawingml/2006/main" xmlns:r="http://schemas.openxmlformats.org/officeDocument/2006/relationships" xmlns:p="http://schemas.openxmlformats.org/presentationml/2006/main">
   <p:cSld>
     <p:bg>
       <p:bgPr>
@@ -11542,7 +11669,14 @@
         <p:cNvGrpSpPr/>
         <p:nvPr/>
       </p:nvGrpSpPr>
-      <p:grpSpPr/>
+      <p:grpSpPr>
+        <a:xfrm>
+          <a:off x="0" y="0"/>
+          <a:ext cx="0" cy="0"/>
+          <a:chOff x="0" y="0"/>
+          <a:chExt cx="0" cy="0"/>
+        </a:xfrm>
+      </p:grpSpPr>
       <p:sp>
         <p:nvSpPr>
           <p:cNvPr id="2" name="Oval 1"/>
@@ -11579,7 +11713,7 @@
           </a:fontRef>
         </p:style>
         <p:txBody>
-          <a:bodyPr rtlCol="0" anchor="ctr" wrap="square"/>
+          <a:bodyPr wrap="square" rtlCol="0" anchor="ctr"/>
           <a:lstStyle/>
           <a:p>
             <a:pPr algn="ctr">
@@ -11683,7 +11817,7 @@
 </file>
 
 <file path=ppt/slides/slide2.xml><?xml version="1.0" encoding="utf-8"?>
-<p:sld xmlns:a="http://schemas.openxmlformats.org/drawingml/2006/main" xmlns:p="http://schemas.openxmlformats.org/presentationml/2006/main" xmlns:r="http://schemas.openxmlformats.org/officeDocument/2006/relationships">
+<p:sld xmlns:a="http://schemas.openxmlformats.org/drawingml/2006/main" xmlns:r="http://schemas.openxmlformats.org/officeDocument/2006/relationships" xmlns:p="http://schemas.openxmlformats.org/presentationml/2006/main">
   <p:cSld>
     <p:bg>
       <p:bgPr>
@@ -11699,7 +11833,14 @@
         <p:cNvGrpSpPr/>
         <p:nvPr/>
       </p:nvGrpSpPr>
-      <p:grpSpPr/>
+      <p:grpSpPr>
+        <a:xfrm>
+          <a:off x="0" y="0"/>
+          <a:ext cx="0" cy="0"/>
+          <a:chOff x="0" y="0"/>
+          <a:chExt cx="0" cy="0"/>
+        </a:xfrm>
+      </p:grpSpPr>
       <p:sp>
         <p:nvSpPr>
           <p:cNvPr id="2" name="Rounded Rectangle 1"/>
@@ -11740,6 +11881,7 @@
           <a:lstStyle/>
           <a:p>
             <a:pPr algn="ctr"/>
+            <a:endParaRPr/>
           </a:p>
         </p:txBody>
       </p:sp>
@@ -11815,7 +11957,7 @@
           </a:fontRef>
         </p:style>
         <p:txBody>
-          <a:bodyPr rtlCol="0" anchor="ctr" wrap="square"/>
+          <a:bodyPr wrap="square" rtlCol="0" anchor="ctr"/>
           <a:lstStyle/>
           <a:p>
             <a:pPr algn="ctr">
@@ -11876,6 +12018,7 @@
           <a:lstStyle/>
           <a:p>
             <a:pPr algn="ctr"/>
+            <a:endParaRPr/>
           </a:p>
         </p:txBody>
       </p:sp>
@@ -11915,7 +12058,7 @@
           </a:fontRef>
         </p:style>
         <p:txBody>
-          <a:bodyPr rtlCol="0" anchor="ctr" wrap="square"/>
+          <a:bodyPr wrap="square" rtlCol="0" anchor="ctr"/>
           <a:lstStyle/>
           <a:p>
             <a:pPr algn="ctr">
@@ -11972,6 +12115,7 @@
           <a:lstStyle/>
           <a:p>
             <a:pPr algn="ctr"/>
+            <a:endParaRPr/>
           </a:p>
         </p:txBody>
       </p:sp>
@@ -12011,7 +12155,7 @@
           </a:fontRef>
         </p:style>
         <p:txBody>
-          <a:bodyPr rtlCol="0" anchor="ctr" wrap="square"/>
+          <a:bodyPr wrap="square" rtlCol="0" anchor="ctr"/>
           <a:lstStyle/>
           <a:p>
             <a:pPr algn="ctr">
@@ -12072,6 +12216,7 @@
           <a:lstStyle/>
           <a:p>
             <a:pPr algn="ctr"/>
+            <a:endParaRPr/>
           </a:p>
         </p:txBody>
       </p:sp>
@@ -12111,7 +12256,7 @@
           </a:fontRef>
         </p:style>
         <p:txBody>
-          <a:bodyPr rtlCol="0" anchor="ctr" wrap="square"/>
+          <a:bodyPr wrap="square" rtlCol="0" anchor="ctr"/>
           <a:lstStyle/>
           <a:p>
             <a:pPr algn="ctr">
@@ -12168,6 +12313,7 @@
           <a:lstStyle/>
           <a:p>
             <a:pPr algn="ctr"/>
+            <a:endParaRPr/>
           </a:p>
         </p:txBody>
       </p:sp>
@@ -12207,7 +12353,7 @@
           </a:fontRef>
         </p:style>
         <p:txBody>
-          <a:bodyPr rtlCol="0" anchor="ctr" wrap="square"/>
+          <a:bodyPr wrap="square" rtlCol="0" anchor="ctr"/>
           <a:lstStyle/>
           <a:p>
             <a:pPr algn="ctr">
@@ -12296,7 +12442,7 @@
           </a:fontRef>
         </p:style>
         <p:txBody>
-          <a:bodyPr rtlCol="0" anchor="ctr" wrap="square"/>
+          <a:bodyPr wrap="square" rtlCol="0" anchor="ctr"/>
           <a:lstStyle/>
           <a:p>
             <a:pPr algn="ctr">
@@ -12459,7 +12605,7 @@
           </a:fontRef>
         </p:style>
         <p:txBody>
-          <a:bodyPr rtlCol="0" anchor="ctr" wrap="square"/>
+          <a:bodyPr wrap="square" rtlCol="0" anchor="ctr"/>
           <a:lstStyle/>
           <a:p>
             <a:pPr algn="ctr">
@@ -12584,7 +12730,7 @@
           </a:fontRef>
         </p:style>
         <p:txBody>
-          <a:bodyPr rtlCol="0" anchor="ctr" wrap="square"/>
+          <a:bodyPr wrap="square" rtlCol="0" anchor="ctr"/>
           <a:lstStyle/>
           <a:p>
             <a:pPr algn="ctr">
@@ -12709,7 +12855,7 @@
           </a:fontRef>
         </p:style>
         <p:txBody>
-          <a:bodyPr rtlCol="0" anchor="ctr" wrap="square"/>
+          <a:bodyPr wrap="square" rtlCol="0" anchor="ctr"/>
           <a:lstStyle/>
           <a:p>
             <a:pPr algn="ctr">
@@ -12870,7 +13016,7 @@
           </a:fontRef>
         </p:style>
         <p:txBody>
-          <a:bodyPr rtlCol="0" anchor="ctr" wrap="square"/>
+          <a:bodyPr wrap="square" rtlCol="0" anchor="ctr"/>
           <a:lstStyle/>
           <a:p>
             <a:pPr algn="ctr">
@@ -12995,7 +13141,7 @@
           </a:fontRef>
         </p:style>
         <p:txBody>
-          <a:bodyPr rtlCol="0" anchor="ctr" wrap="square"/>
+          <a:bodyPr wrap="square" rtlCol="0" anchor="ctr"/>
           <a:lstStyle/>
           <a:p>
             <a:pPr algn="ctr">
@@ -13120,7 +13266,7 @@
           </a:fontRef>
         </p:style>
         <p:txBody>
-          <a:bodyPr rtlCol="0" anchor="ctr" wrap="square"/>
+          <a:bodyPr wrap="square" rtlCol="0" anchor="ctr"/>
           <a:lstStyle/>
           <a:p>
             <a:pPr algn="ctr">
@@ -13245,7 +13391,7 @@
           </a:fontRef>
         </p:style>
         <p:txBody>
-          <a:bodyPr rtlCol="0" anchor="ctr" wrap="square"/>
+          <a:bodyPr wrap="square" rtlCol="0" anchor="ctr"/>
           <a:lstStyle/>
           <a:p>
             <a:pPr algn="ctr">
@@ -13370,7 +13516,7 @@
           </a:fontRef>
         </p:style>
         <p:txBody>
-          <a:bodyPr rtlCol="0" anchor="ctr" wrap="square"/>
+          <a:bodyPr wrap="square" rtlCol="0" anchor="ctr"/>
           <a:lstStyle/>
           <a:p>
             <a:pPr algn="ctr">
@@ -13495,7 +13641,7 @@
           </a:fontRef>
         </p:style>
         <p:txBody>
-          <a:bodyPr rtlCol="0" anchor="ctr" wrap="square"/>
+          <a:bodyPr wrap="square" rtlCol="0" anchor="ctr"/>
           <a:lstStyle/>
           <a:p>
             <a:pPr algn="ctr">
@@ -13593,7 +13739,7 @@
 </file>
 
 <file path=ppt/slides/slide20.xml><?xml version="1.0" encoding="utf-8"?>
-<p:sld xmlns:a="http://schemas.openxmlformats.org/drawingml/2006/main" xmlns:p="http://schemas.openxmlformats.org/presentationml/2006/main" xmlns:r="http://schemas.openxmlformats.org/officeDocument/2006/relationships">
+<p:sld xmlns:a="http://schemas.openxmlformats.org/drawingml/2006/main" xmlns:r="http://schemas.openxmlformats.org/officeDocument/2006/relationships" xmlns:p="http://schemas.openxmlformats.org/presentationml/2006/main">
   <p:cSld>
     <p:bg>
       <p:bgPr>
@@ -13609,7 +13755,14 @@
         <p:cNvGrpSpPr/>
         <p:nvPr/>
       </p:nvGrpSpPr>
-      <p:grpSpPr/>
+      <p:grpSpPr>
+        <a:xfrm>
+          <a:off x="0" y="0"/>
+          <a:ext cx="0" cy="0"/>
+          <a:chOff x="0" y="0"/>
+          <a:chExt cx="0" cy="0"/>
+        </a:xfrm>
+      </p:grpSpPr>
       <p:sp>
         <p:nvSpPr>
           <p:cNvPr id="2" name="Rounded Rectangle 1"/>
@@ -13650,6 +13803,7 @@
           <a:lstStyle/>
           <a:p>
             <a:pPr algn="ctr"/>
+            <a:endParaRPr/>
           </a:p>
         </p:txBody>
       </p:sp>
@@ -13767,6 +13921,7 @@
           <a:lstStyle/>
           <a:p>
             <a:pPr algn="ctr"/>
+            <a:endParaRPr/>
           </a:p>
         </p:txBody>
       </p:sp>
@@ -13919,6 +14074,7 @@
           <a:lstStyle/>
           <a:p>
             <a:pPr algn="ctr"/>
+            <a:endParaRPr/>
           </a:p>
         </p:txBody>
       </p:sp>
@@ -14071,6 +14227,7 @@
                 <a:latin typeface="Calibri"/>
               </a:defRPr>
             </a:pPr>
+            <a:endParaRPr/>
           </a:p>
           <a:p>
             <a:pPr>
@@ -14148,6 +14305,7 @@
           <a:lstStyle/>
           <a:p>
             <a:pPr algn="ctr"/>
+            <a:endParaRPr/>
           </a:p>
         </p:txBody>
       </p:sp>
@@ -14300,6 +14458,7 @@
                 <a:latin typeface="Calibri"/>
               </a:defRPr>
             </a:pPr>
+            <a:endParaRPr/>
           </a:p>
           <a:p>
             <a:pPr>
@@ -14377,6 +14536,7 @@
           <a:lstStyle/>
           <a:p>
             <a:pPr algn="ctr"/>
+            <a:endParaRPr/>
           </a:p>
         </p:txBody>
       </p:sp>
@@ -14429,7 +14589,7 @@
 </file>
 
 <file path=ppt/slides/slide21.xml><?xml version="1.0" encoding="utf-8"?>
-<p:sld xmlns:a="http://schemas.openxmlformats.org/drawingml/2006/main" xmlns:p="http://schemas.openxmlformats.org/presentationml/2006/main" xmlns:r="http://schemas.openxmlformats.org/officeDocument/2006/relationships">
+<p:sld xmlns:a="http://schemas.openxmlformats.org/drawingml/2006/main" xmlns:r="http://schemas.openxmlformats.org/officeDocument/2006/relationships" xmlns:p="http://schemas.openxmlformats.org/presentationml/2006/main">
   <p:cSld>
     <p:bg>
       <p:bgPr>
@@ -14445,7 +14605,14 @@
         <p:cNvGrpSpPr/>
         <p:nvPr/>
       </p:nvGrpSpPr>
-      <p:grpSpPr/>
+      <p:grpSpPr>
+        <a:xfrm>
+          <a:off x="0" y="0"/>
+          <a:ext cx="0" cy="0"/>
+          <a:chOff x="0" y="0"/>
+          <a:chExt cx="0" cy="0"/>
+        </a:xfrm>
+      </p:grpSpPr>
       <p:sp>
         <p:nvSpPr>
           <p:cNvPr id="2" name="Rounded Rectangle 1"/>
@@ -14486,6 +14653,7 @@
           <a:lstStyle/>
           <a:p>
             <a:pPr algn="ctr"/>
+            <a:endParaRPr/>
           </a:p>
         </p:txBody>
       </p:sp>
@@ -14601,6 +14769,7 @@
           <a:lstStyle/>
           <a:p>
             <a:pPr algn="ctr"/>
+            <a:endParaRPr/>
           </a:p>
         </p:txBody>
       </p:sp>
@@ -14653,6 +14822,7 @@
                 <a:latin typeface="Courier New"/>
               </a:defRPr>
             </a:pPr>
+            <a:endParaRPr/>
           </a:p>
           <a:p>
             <a:pPr>
@@ -14698,6 +14868,7 @@
                 <a:latin typeface="Courier New"/>
               </a:defRPr>
             </a:pPr>
+            <a:endParaRPr/>
           </a:p>
           <a:p>
             <a:pPr>
@@ -14951,6 +15122,7 @@
                 <a:latin typeface="Courier New"/>
               </a:defRPr>
             </a:pPr>
+            <a:endParaRPr/>
           </a:p>
           <a:p>
             <a:pPr>
@@ -15012,6 +15184,7 @@
                 <a:latin typeface="Courier New"/>
               </a:defRPr>
             </a:pPr>
+            <a:endParaRPr/>
           </a:p>
           <a:p>
             <a:pPr>
@@ -15119,7 +15292,7 @@
           </a:fontRef>
         </p:style>
         <p:txBody>
-          <a:bodyPr rtlCol="0" anchor="ctr" wrap="square"/>
+          <a:bodyPr wrap="square" rtlCol="0" anchor="ctr"/>
           <a:lstStyle/>
           <a:p>
             <a:pPr algn="ctr">
@@ -15216,7 +15389,7 @@
           </a:fontRef>
         </p:style>
         <p:txBody>
-          <a:bodyPr rtlCol="0" anchor="ctr" wrap="square"/>
+          <a:bodyPr wrap="square" rtlCol="0" anchor="ctr"/>
           <a:lstStyle/>
           <a:p>
             <a:pPr algn="ctr">
@@ -15313,7 +15486,7 @@
           </a:fontRef>
         </p:style>
         <p:txBody>
-          <a:bodyPr rtlCol="0" anchor="ctr" wrap="square"/>
+          <a:bodyPr wrap="square" rtlCol="0" anchor="ctr"/>
           <a:lstStyle/>
           <a:p>
             <a:pPr algn="ctr">
@@ -15410,7 +15583,7 @@
           </a:fontRef>
         </p:style>
         <p:txBody>
-          <a:bodyPr rtlCol="0" anchor="ctr" wrap="square"/>
+          <a:bodyPr wrap="square" rtlCol="0" anchor="ctr"/>
           <a:lstStyle/>
           <a:p>
             <a:pPr algn="ctr">
@@ -15513,6 +15686,7 @@
           <a:lstStyle/>
           <a:p>
             <a:pPr algn="ctr"/>
+            <a:endParaRPr/>
           </a:p>
         </p:txBody>
       </p:sp>
@@ -15632,7 +15806,7 @@
 </file>
 
 <file path=ppt/slides/slide22.xml><?xml version="1.0" encoding="utf-8"?>
-<p:sld xmlns:a="http://schemas.openxmlformats.org/drawingml/2006/main" xmlns:p="http://schemas.openxmlformats.org/presentationml/2006/main" xmlns:r="http://schemas.openxmlformats.org/officeDocument/2006/relationships">
+<p:sld xmlns:a="http://schemas.openxmlformats.org/drawingml/2006/main" xmlns:r="http://schemas.openxmlformats.org/officeDocument/2006/relationships" xmlns:p="http://schemas.openxmlformats.org/presentationml/2006/main">
   <p:cSld>
     <p:bg>
       <p:bgPr>
@@ -15648,7 +15822,14 @@
         <p:cNvGrpSpPr/>
         <p:nvPr/>
       </p:nvGrpSpPr>
-      <p:grpSpPr/>
+      <p:grpSpPr>
+        <a:xfrm>
+          <a:off x="0" y="0"/>
+          <a:ext cx="0" cy="0"/>
+          <a:chOff x="0" y="0"/>
+          <a:chExt cx="0" cy="0"/>
+        </a:xfrm>
+      </p:grpSpPr>
       <p:sp>
         <p:nvSpPr>
           <p:cNvPr id="2" name="Oval 1"/>
@@ -15685,7 +15866,7 @@
           </a:fontRef>
         </p:style>
         <p:txBody>
-          <a:bodyPr rtlCol="0" anchor="ctr" wrap="square"/>
+          <a:bodyPr wrap="square" rtlCol="0" anchor="ctr"/>
           <a:lstStyle/>
           <a:p>
             <a:pPr algn="ctr">
@@ -15789,7 +15970,7 @@
 </file>
 
 <file path=ppt/slides/slide23.xml><?xml version="1.0" encoding="utf-8"?>
-<p:sld xmlns:a="http://schemas.openxmlformats.org/drawingml/2006/main" xmlns:p="http://schemas.openxmlformats.org/presentationml/2006/main" xmlns:r="http://schemas.openxmlformats.org/officeDocument/2006/relationships">
+<p:sld xmlns:a="http://schemas.openxmlformats.org/drawingml/2006/main" xmlns:r="http://schemas.openxmlformats.org/officeDocument/2006/relationships" xmlns:p="http://schemas.openxmlformats.org/presentationml/2006/main">
   <p:cSld>
     <p:bg>
       <p:bgPr>
@@ -15805,7 +15986,14 @@
         <p:cNvGrpSpPr/>
         <p:nvPr/>
       </p:nvGrpSpPr>
-      <p:grpSpPr/>
+      <p:grpSpPr>
+        <a:xfrm>
+          <a:off x="0" y="0"/>
+          <a:ext cx="0" cy="0"/>
+          <a:chOff x="0" y="0"/>
+          <a:chExt cx="0" cy="0"/>
+        </a:xfrm>
+      </p:grpSpPr>
       <p:sp>
         <p:nvSpPr>
           <p:cNvPr id="2" name="Rounded Rectangle 1"/>
@@ -15846,6 +16034,7 @@
           <a:lstStyle/>
           <a:p>
             <a:pPr algn="ctr"/>
+            <a:endParaRPr/>
           </a:p>
         </p:txBody>
       </p:sp>
@@ -15963,6 +16152,7 @@
           <a:lstStyle/>
           <a:p>
             <a:pPr algn="ctr"/>
+            <a:endParaRPr/>
           </a:p>
         </p:txBody>
       </p:sp>
@@ -16115,6 +16305,7 @@
           <a:lstStyle/>
           <a:p>
             <a:pPr algn="ctr"/>
+            <a:endParaRPr/>
           </a:p>
         </p:txBody>
       </p:sp>
@@ -16203,6 +16394,7 @@
                 <a:latin typeface="Calibri"/>
               </a:defRPr>
             </a:pPr>
+            <a:endParaRPr/>
           </a:p>
           <a:p>
             <a:pPr>
@@ -16328,6 +16520,7 @@
           <a:lstStyle/>
           <a:p>
             <a:pPr algn="ctr"/>
+            <a:endParaRPr/>
           </a:p>
         </p:txBody>
       </p:sp>
@@ -16416,6 +16609,7 @@
                 <a:latin typeface="Calibri"/>
               </a:defRPr>
             </a:pPr>
+            <a:endParaRPr/>
           </a:p>
           <a:p>
             <a:pPr>
@@ -16541,6 +16735,7 @@
           <a:lstStyle/>
           <a:p>
             <a:pPr algn="ctr"/>
+            <a:endParaRPr/>
           </a:p>
         </p:txBody>
       </p:sp>
@@ -16593,7 +16788,7 @@
 </file>
 
 <file path=ppt/slides/slide24.xml><?xml version="1.0" encoding="utf-8"?>
-<p:sld xmlns:a="http://schemas.openxmlformats.org/drawingml/2006/main" xmlns:p="http://schemas.openxmlformats.org/presentationml/2006/main" xmlns:r="http://schemas.openxmlformats.org/officeDocument/2006/relationships">
+<p:sld xmlns:a="http://schemas.openxmlformats.org/drawingml/2006/main" xmlns:r="http://schemas.openxmlformats.org/officeDocument/2006/relationships" xmlns:p="http://schemas.openxmlformats.org/presentationml/2006/main">
   <p:cSld>
     <p:bg>
       <p:bgPr>
@@ -16609,7 +16804,14 @@
         <p:cNvGrpSpPr/>
         <p:nvPr/>
       </p:nvGrpSpPr>
-      <p:grpSpPr/>
+      <p:grpSpPr>
+        <a:xfrm>
+          <a:off x="0" y="0"/>
+          <a:ext cx="0" cy="0"/>
+          <a:chOff x="0" y="0"/>
+          <a:chExt cx="0" cy="0"/>
+        </a:xfrm>
+      </p:grpSpPr>
       <p:sp>
         <p:nvSpPr>
           <p:cNvPr id="2" name="Rounded Rectangle 1"/>
@@ -16650,6 +16852,7 @@
           <a:lstStyle/>
           <a:p>
             <a:pPr algn="ctr"/>
+            <a:endParaRPr/>
           </a:p>
         </p:txBody>
       </p:sp>
@@ -16803,6 +17006,7 @@
           <a:lstStyle/>
           <a:p>
             <a:pPr algn="ctr"/>
+            <a:endParaRPr/>
           </a:p>
         </p:txBody>
       </p:sp>
@@ -16891,6 +17095,7 @@
                 <a:latin typeface="Calibri"/>
               </a:defRPr>
             </a:pPr>
+            <a:endParaRPr/>
           </a:p>
           <a:p>
             <a:pPr>
@@ -16984,6 +17189,7 @@
                 <a:latin typeface="Calibri"/>
               </a:defRPr>
             </a:pPr>
+            <a:endParaRPr/>
           </a:p>
           <a:p>
             <a:pPr>
@@ -17059,6 +17265,7 @@
           <a:lstStyle/>
           <a:p>
             <a:pPr algn="ctr"/>
+            <a:endParaRPr/>
           </a:p>
         </p:txBody>
       </p:sp>
@@ -17104,6 +17311,7 @@
           <a:lstStyle/>
           <a:p>
             <a:pPr algn="ctr"/>
+            <a:endParaRPr/>
           </a:p>
         </p:txBody>
       </p:sp>
@@ -17192,6 +17400,7 @@
                 <a:latin typeface="Calibri"/>
               </a:defRPr>
             </a:pPr>
+            <a:endParaRPr/>
           </a:p>
           <a:p>
             <a:pPr>
@@ -17285,6 +17494,7 @@
                 <a:latin typeface="Calibri"/>
               </a:defRPr>
             </a:pPr>
+            <a:endParaRPr/>
           </a:p>
           <a:p>
             <a:pPr>
@@ -17362,6 +17572,7 @@
           <a:lstStyle/>
           <a:p>
             <a:pPr algn="ctr"/>
+            <a:endParaRPr/>
           </a:p>
         </p:txBody>
       </p:sp>
@@ -17466,6 +17677,7 @@
                 <a:latin typeface="Calibri"/>
               </a:defRPr>
             </a:pPr>
+            <a:endParaRPr/>
           </a:p>
           <a:p>
             <a:pPr>
@@ -17511,6 +17723,7 @@
                 <a:latin typeface="Calibri"/>
               </a:defRPr>
             </a:pPr>
+            <a:endParaRPr/>
           </a:p>
           <a:p>
             <a:pPr>
@@ -17539,7 +17752,7 @@
 </file>
 
 <file path=ppt/slides/slide25.xml><?xml version="1.0" encoding="utf-8"?>
-<p:sld xmlns:a="http://schemas.openxmlformats.org/drawingml/2006/main" xmlns:p="http://schemas.openxmlformats.org/presentationml/2006/main" xmlns:r="http://schemas.openxmlformats.org/officeDocument/2006/relationships">
+<p:sld xmlns:a="http://schemas.openxmlformats.org/drawingml/2006/main" xmlns:r="http://schemas.openxmlformats.org/officeDocument/2006/relationships" xmlns:p="http://schemas.openxmlformats.org/presentationml/2006/main">
   <p:cSld>
     <p:bg>
       <p:bgPr>
@@ -17555,7 +17768,14 @@
         <p:cNvGrpSpPr/>
         <p:nvPr/>
       </p:nvGrpSpPr>
-      <p:grpSpPr/>
+      <p:grpSpPr>
+        <a:xfrm>
+          <a:off x="0" y="0"/>
+          <a:ext cx="0" cy="0"/>
+          <a:chOff x="0" y="0"/>
+          <a:chExt cx="0" cy="0"/>
+        </a:xfrm>
+      </p:grpSpPr>
       <p:sp>
         <p:nvSpPr>
           <p:cNvPr id="2" name="Rounded Rectangle 1"/>
@@ -17596,6 +17816,7 @@
           <a:lstStyle/>
           <a:p>
             <a:pPr algn="ctr"/>
+            <a:endParaRPr/>
           </a:p>
         </p:txBody>
       </p:sp>
@@ -17749,6 +17970,7 @@
           <a:lstStyle/>
           <a:p>
             <a:pPr algn="ctr"/>
+            <a:endParaRPr/>
           </a:p>
         </p:txBody>
       </p:sp>
@@ -17853,6 +18075,7 @@
                 <a:latin typeface="Courier New"/>
               </a:defRPr>
             </a:pPr>
+            <a:endParaRPr/>
           </a:p>
           <a:p>
             <a:pPr>
@@ -17946,6 +18169,7 @@
                 <a:latin typeface="Courier New"/>
               </a:defRPr>
             </a:pPr>
+            <a:endParaRPr/>
           </a:p>
           <a:p>
             <a:pPr>
@@ -18023,6 +18247,7 @@
           <a:lstStyle/>
           <a:p>
             <a:pPr algn="ctr"/>
+            <a:endParaRPr/>
           </a:p>
         </p:txBody>
       </p:sp>
@@ -18127,6 +18352,7 @@
                 <a:latin typeface="Courier New"/>
               </a:defRPr>
             </a:pPr>
+            <a:endParaRPr/>
           </a:p>
           <a:p>
             <a:pPr>
@@ -18252,6 +18478,7 @@
                 <a:latin typeface="Courier New"/>
               </a:defRPr>
             </a:pPr>
+            <a:endParaRPr/>
           </a:p>
           <a:p>
             <a:pPr>
@@ -18329,6 +18556,7 @@
           <a:lstStyle/>
           <a:p>
             <a:pPr algn="ctr"/>
+            <a:endParaRPr/>
           </a:p>
         </p:txBody>
       </p:sp>
@@ -18433,6 +18661,7 @@
                 <a:latin typeface="Calibri"/>
               </a:defRPr>
             </a:pPr>
+            <a:endParaRPr/>
           </a:p>
           <a:p>
             <a:pPr>
@@ -18477,7 +18706,7 @@
 </file>
 
 <file path=ppt/slides/slide26.xml><?xml version="1.0" encoding="utf-8"?>
-<p:sld xmlns:a="http://schemas.openxmlformats.org/drawingml/2006/main" xmlns:p="http://schemas.openxmlformats.org/presentationml/2006/main" xmlns:r="http://schemas.openxmlformats.org/officeDocument/2006/relationships">
+<p:sld xmlns:a="http://schemas.openxmlformats.org/drawingml/2006/main" xmlns:r="http://schemas.openxmlformats.org/officeDocument/2006/relationships" xmlns:p="http://schemas.openxmlformats.org/presentationml/2006/main">
   <p:cSld>
     <p:bg>
       <p:bgPr>
@@ -18493,7 +18722,14 @@
         <p:cNvGrpSpPr/>
         <p:nvPr/>
       </p:nvGrpSpPr>
-      <p:grpSpPr/>
+      <p:grpSpPr>
+        <a:xfrm>
+          <a:off x="0" y="0"/>
+          <a:ext cx="0" cy="0"/>
+          <a:chOff x="0" y="0"/>
+          <a:chExt cx="0" cy="0"/>
+        </a:xfrm>
+      </p:grpSpPr>
       <p:sp>
         <p:nvSpPr>
           <p:cNvPr id="2" name="Rounded Rectangle 1"/>
@@ -18534,6 +18770,7 @@
           <a:lstStyle/>
           <a:p>
             <a:pPr algn="ctr"/>
+            <a:endParaRPr/>
           </a:p>
         </p:txBody>
       </p:sp>
@@ -18645,7 +18882,7 @@
           </a:fontRef>
         </p:style>
         <p:txBody>
-          <a:bodyPr rtlCol="0" anchor="ctr" wrap="square"/>
+          <a:bodyPr wrap="square" rtlCol="0" anchor="ctr"/>
           <a:lstStyle/>
           <a:p>
             <a:pPr algn="ctr">
@@ -18738,7 +18975,7 @@
           </a:fontRef>
         </p:style>
         <p:txBody>
-          <a:bodyPr rtlCol="0" anchor="ctr" wrap="square"/>
+          <a:bodyPr wrap="square" rtlCol="0" anchor="ctr"/>
           <a:lstStyle/>
           <a:p>
             <a:pPr algn="ctr">
@@ -18831,7 +19068,7 @@
           </a:fontRef>
         </p:style>
         <p:txBody>
-          <a:bodyPr rtlCol="0" anchor="ctr" wrap="square"/>
+          <a:bodyPr wrap="square" rtlCol="0" anchor="ctr"/>
           <a:lstStyle/>
           <a:p>
             <a:pPr algn="ctr">
@@ -18924,7 +19161,7 @@
           </a:fontRef>
         </p:style>
         <p:txBody>
-          <a:bodyPr rtlCol="0" anchor="ctr" wrap="square"/>
+          <a:bodyPr wrap="square" rtlCol="0" anchor="ctr"/>
           <a:lstStyle/>
           <a:p>
             <a:pPr algn="ctr">
@@ -19017,7 +19254,7 @@
           </a:fontRef>
         </p:style>
         <p:txBody>
-          <a:bodyPr rtlCol="0" anchor="ctr" wrap="square"/>
+          <a:bodyPr wrap="square" rtlCol="0" anchor="ctr"/>
           <a:lstStyle/>
           <a:p>
             <a:pPr algn="ctr">
@@ -19110,7 +19347,7 @@
           </a:fontRef>
         </p:style>
         <p:txBody>
-          <a:bodyPr rtlCol="0" anchor="ctr" wrap="square"/>
+          <a:bodyPr wrap="square" rtlCol="0" anchor="ctr"/>
           <a:lstStyle/>
           <a:p>
             <a:pPr algn="ctr">
@@ -19176,7 +19413,7 @@
 </file>
 
 <file path=ppt/slides/slide27.xml><?xml version="1.0" encoding="utf-8"?>
-<p:sld xmlns:a="http://schemas.openxmlformats.org/drawingml/2006/main" xmlns:p="http://schemas.openxmlformats.org/presentationml/2006/main" xmlns:r="http://schemas.openxmlformats.org/officeDocument/2006/relationships">
+<p:sld xmlns:a="http://schemas.openxmlformats.org/drawingml/2006/main" xmlns:r="http://schemas.openxmlformats.org/officeDocument/2006/relationships" xmlns:p="http://schemas.openxmlformats.org/presentationml/2006/main">
   <p:cSld>
     <p:bg>
       <p:bgPr>
@@ -19192,7 +19429,14 @@
         <p:cNvGrpSpPr/>
         <p:nvPr/>
       </p:nvGrpSpPr>
-      <p:grpSpPr/>
+      <p:grpSpPr>
+        <a:xfrm>
+          <a:off x="0" y="0"/>
+          <a:ext cx="0" cy="0"/>
+          <a:chOff x="0" y="0"/>
+          <a:chExt cx="0" cy="0"/>
+        </a:xfrm>
+      </p:grpSpPr>
       <p:sp>
         <p:nvSpPr>
           <p:cNvPr id="2" name="TextBox 1"/>
@@ -19265,7 +19509,7 @@
           </a:fontRef>
         </p:style>
         <p:txBody>
-          <a:bodyPr rtlCol="0" anchor="ctr" wrap="square"/>
+          <a:bodyPr wrap="square" rtlCol="0" anchor="ctr"/>
           <a:lstStyle/>
           <a:p>
             <a:pPr algn="ctr">
@@ -19390,7 +19634,7 @@
           </a:fontRef>
         </p:style>
         <p:txBody>
-          <a:bodyPr rtlCol="0" anchor="ctr" wrap="square"/>
+          <a:bodyPr wrap="square" rtlCol="0" anchor="ctr"/>
           <a:lstStyle/>
           <a:p>
             <a:pPr algn="ctr">
@@ -19515,7 +19759,7 @@
           </a:fontRef>
         </p:style>
         <p:txBody>
-          <a:bodyPr rtlCol="0" anchor="ctr" wrap="square"/>
+          <a:bodyPr wrap="square" rtlCol="0" anchor="ctr"/>
           <a:lstStyle/>
           <a:p>
             <a:pPr algn="ctr">
@@ -19640,7 +19884,7 @@
           </a:fontRef>
         </p:style>
         <p:txBody>
-          <a:bodyPr rtlCol="0" anchor="ctr" wrap="square"/>
+          <a:bodyPr wrap="square" rtlCol="0" anchor="ctr"/>
           <a:lstStyle/>
           <a:p>
             <a:pPr algn="ctr">
@@ -19765,7 +20009,7 @@
           </a:fontRef>
         </p:style>
         <p:txBody>
-          <a:bodyPr rtlCol="0" anchor="ctr" wrap="square"/>
+          <a:bodyPr wrap="square" rtlCol="0" anchor="ctr"/>
           <a:lstStyle/>
           <a:p>
             <a:pPr algn="ctr">
@@ -19890,7 +20134,7 @@
           </a:fontRef>
         </p:style>
         <p:txBody>
-          <a:bodyPr rtlCol="0" anchor="ctr" wrap="square"/>
+          <a:bodyPr wrap="square" rtlCol="0" anchor="ctr"/>
           <a:lstStyle/>
           <a:p>
             <a:pPr algn="ctr">
@@ -20019,6 +20263,7 @@
           <a:lstStyle/>
           <a:p>
             <a:pPr algn="ctr"/>
+            <a:endParaRPr/>
           </a:p>
         </p:txBody>
       </p:sp>
@@ -20067,7 +20312,7 @@
 </file>
 
 <file path=ppt/slides/slide3.xml><?xml version="1.0" encoding="utf-8"?>
-<p:sld xmlns:a="http://schemas.openxmlformats.org/drawingml/2006/main" xmlns:p="http://schemas.openxmlformats.org/presentationml/2006/main" xmlns:r="http://schemas.openxmlformats.org/officeDocument/2006/relationships">
+<p:sld xmlns:a="http://schemas.openxmlformats.org/drawingml/2006/main" xmlns:r="http://schemas.openxmlformats.org/officeDocument/2006/relationships" xmlns:p="http://schemas.openxmlformats.org/presentationml/2006/main">
   <p:cSld>
     <p:bg>
       <p:bgPr>
@@ -20083,7 +20328,14 @@
         <p:cNvGrpSpPr/>
         <p:nvPr/>
       </p:nvGrpSpPr>
-      <p:grpSpPr/>
+      <p:grpSpPr>
+        <a:xfrm>
+          <a:off x="0" y="0"/>
+          <a:ext cx="0" cy="0"/>
+          <a:chOff x="0" y="0"/>
+          <a:chExt cx="0" cy="0"/>
+        </a:xfrm>
+      </p:grpSpPr>
       <p:sp>
         <p:nvSpPr>
           <p:cNvPr id="2" name="Oval 1"/>
@@ -20120,7 +20372,7 @@
           </a:fontRef>
         </p:style>
         <p:txBody>
-          <a:bodyPr rtlCol="0" anchor="ctr" wrap="square"/>
+          <a:bodyPr wrap="square" rtlCol="0" anchor="ctr"/>
           <a:lstStyle/>
           <a:p>
             <a:pPr algn="ctr">
@@ -20224,7 +20476,7 @@
 </file>
 
 <file path=ppt/slides/slide4.xml><?xml version="1.0" encoding="utf-8"?>
-<p:sld xmlns:a="http://schemas.openxmlformats.org/drawingml/2006/main" xmlns:p="http://schemas.openxmlformats.org/presentationml/2006/main" xmlns:r="http://schemas.openxmlformats.org/officeDocument/2006/relationships">
+<p:sld xmlns:a="http://schemas.openxmlformats.org/drawingml/2006/main" xmlns:r="http://schemas.openxmlformats.org/officeDocument/2006/relationships" xmlns:p="http://schemas.openxmlformats.org/presentationml/2006/main">
   <p:cSld>
     <p:bg>
       <p:bgPr>
@@ -20240,7 +20492,14 @@
         <p:cNvGrpSpPr/>
         <p:nvPr/>
       </p:nvGrpSpPr>
-      <p:grpSpPr/>
+      <p:grpSpPr>
+        <a:xfrm>
+          <a:off x="0" y="0"/>
+          <a:ext cx="0" cy="0"/>
+          <a:chOff x="0" y="0"/>
+          <a:chExt cx="0" cy="0"/>
+        </a:xfrm>
+      </p:grpSpPr>
       <p:sp>
         <p:nvSpPr>
           <p:cNvPr id="2" name="Rounded Rectangle 1"/>
@@ -20281,6 +20540,7 @@
           <a:lstStyle/>
           <a:p>
             <a:pPr algn="ctr"/>
+            <a:endParaRPr/>
           </a:p>
         </p:txBody>
       </p:sp>
@@ -20398,6 +20658,7 @@
           <a:lstStyle/>
           <a:p>
             <a:pPr algn="ctr"/>
+            <a:endParaRPr/>
           </a:p>
         </p:txBody>
       </p:sp>
@@ -20544,7 +20805,7 @@
           </a:fontRef>
         </p:style>
         <p:txBody>
-          <a:bodyPr rtlCol="0" anchor="ctr" wrap="square"/>
+          <a:bodyPr wrap="square" rtlCol="0" anchor="ctr"/>
           <a:lstStyle/>
           <a:p>
             <a:pPr algn="ctr">
@@ -20607,6 +20868,7 @@
           <a:lstStyle/>
           <a:p>
             <a:pPr algn="ctr"/>
+            <a:endParaRPr/>
           </a:p>
         </p:txBody>
       </p:sp>
@@ -20705,6 +20967,7 @@
           <a:lstStyle/>
           <a:p>
             <a:pPr algn="ctr"/>
+            <a:endParaRPr/>
           </a:p>
         </p:txBody>
       </p:sp>
@@ -20792,7 +21055,7 @@
           </a:fontRef>
         </p:style>
         <p:txBody>
-          <a:bodyPr rtlCol="0" anchor="ctr" wrap="square"/>
+          <a:bodyPr wrap="square" rtlCol="0" anchor="ctr"/>
           <a:lstStyle/>
           <a:p>
             <a:pPr algn="ctr">
@@ -20855,6 +21118,7 @@
           <a:lstStyle/>
           <a:p>
             <a:pPr algn="ctr"/>
+            <a:endParaRPr/>
           </a:p>
         </p:txBody>
       </p:sp>
@@ -20953,6 +21217,7 @@
           <a:lstStyle/>
           <a:p>
             <a:pPr algn="ctr"/>
+            <a:endParaRPr/>
           </a:p>
         </p:txBody>
       </p:sp>
@@ -21040,7 +21305,7 @@
           </a:fontRef>
         </p:style>
         <p:txBody>
-          <a:bodyPr rtlCol="0" anchor="ctr" wrap="square"/>
+          <a:bodyPr wrap="square" rtlCol="0" anchor="ctr"/>
           <a:lstStyle/>
           <a:p>
             <a:pPr algn="ctr">
@@ -21103,6 +21368,7 @@
           <a:lstStyle/>
           <a:p>
             <a:pPr algn="ctr"/>
+            <a:endParaRPr/>
           </a:p>
         </p:txBody>
       </p:sp>
@@ -21197,6 +21463,7 @@
           <a:lstStyle/>
           <a:p>
             <a:pPr algn="ctr"/>
+            <a:endParaRPr/>
           </a:p>
         </p:txBody>
       </p:sp>
@@ -21253,7 +21520,7 @@
 </file>
 
 <file path=ppt/slides/slide5.xml><?xml version="1.0" encoding="utf-8"?>
-<p:sld xmlns:a="http://schemas.openxmlformats.org/drawingml/2006/main" xmlns:p="http://schemas.openxmlformats.org/presentationml/2006/main" xmlns:r="http://schemas.openxmlformats.org/officeDocument/2006/relationships">
+<p:sld xmlns:a="http://schemas.openxmlformats.org/drawingml/2006/main" xmlns:r="http://schemas.openxmlformats.org/officeDocument/2006/relationships" xmlns:p="http://schemas.openxmlformats.org/presentationml/2006/main">
   <p:cSld>
     <p:bg>
       <p:bgPr>
@@ -21269,7 +21536,14 @@
         <p:cNvGrpSpPr/>
         <p:nvPr/>
       </p:nvGrpSpPr>
-      <p:grpSpPr/>
+      <p:grpSpPr>
+        <a:xfrm>
+          <a:off x="0" y="0"/>
+          <a:ext cx="0" cy="0"/>
+          <a:chOff x="0" y="0"/>
+          <a:chExt cx="0" cy="0"/>
+        </a:xfrm>
+      </p:grpSpPr>
       <p:sp>
         <p:nvSpPr>
           <p:cNvPr id="2" name="Rounded Rectangle 1"/>
@@ -21310,6 +21584,7 @@
           <a:lstStyle/>
           <a:p>
             <a:pPr algn="ctr"/>
+            <a:endParaRPr/>
           </a:p>
         </p:txBody>
       </p:sp>
@@ -21463,6 +21738,7 @@
           <a:lstStyle/>
           <a:p>
             <a:pPr algn="ctr"/>
+            <a:endParaRPr/>
           </a:p>
         </p:txBody>
       </p:sp>
@@ -21511,7 +21787,7 @@
         <p:spPr>
           <a:xfrm>
             <a:off x="731520" y="2194560"/>
-            <a:ext cx="4846320" cy="2194560"/>
+            <a:ext cx="4846320" cy="2208297"/>
           </a:xfrm>
           <a:prstGeom prst="rect">
             <a:avLst/>
@@ -21536,6 +21812,12 @@
               </a:defRPr>
             </a:pPr>
             <a:r>
+              <a:rPr sz="1000" b="1" dirty="0">
+                <a:solidFill>
+                  <a:srgbClr val="7F8C8D"/>
+                </a:solidFill>
+                <a:latin typeface="Courier New"/>
+              </a:rPr>
               <a:t>"Review this code and find any</a:t>
             </a:r>
           </a:p>
@@ -21552,6 +21834,12 @@
               </a:defRPr>
             </a:pPr>
             <a:r>
+              <a:rPr sz="1000" b="1" dirty="0">
+                <a:solidFill>
+                  <a:srgbClr val="7F8C8D"/>
+                </a:solidFill>
+                <a:latin typeface="Courier New"/>
+              </a:rPr>
               <a:t> issues that might be important."</a:t>
             </a:r>
           </a:p>
@@ -21567,6 +21855,12 @@
                 <a:latin typeface="Courier New"/>
               </a:defRPr>
             </a:pPr>
+            <a:endParaRPr sz="1000" dirty="0">
+              <a:solidFill>
+                <a:srgbClr val="7F8C8D"/>
+              </a:solidFill>
+              <a:latin typeface="Courier New"/>
+            </a:endParaRPr>
           </a:p>
           <a:p>
             <a:pPr>
@@ -21581,6 +21875,7 @@
               </a:defRPr>
             </a:pPr>
             <a:r>
+              <a:rPr sz="1000" dirty="0"/>
               <a:t>Problems:</a:t>
             </a:r>
           </a:p>
@@ -21597,6 +21892,7 @@
               </a:defRPr>
             </a:pPr>
             <a:r>
+              <a:rPr sz="1000" dirty="0"/>
               <a:t>- What counts as 'important'?</a:t>
             </a:r>
           </a:p>
@@ -21613,6 +21909,7 @@
               </a:defRPr>
             </a:pPr>
             <a:r>
+              <a:rPr sz="1000" dirty="0"/>
               <a:t>- No categories defined</a:t>
             </a:r>
           </a:p>
@@ -21629,6 +21926,7 @@
               </a:defRPr>
             </a:pPr>
             <a:r>
+              <a:rPr sz="1000" dirty="0"/>
               <a:t>- No severity levels</a:t>
             </a:r>
           </a:p>
@@ -21645,6 +21943,7 @@
               </a:defRPr>
             </a:pPr>
             <a:r>
+              <a:rPr sz="1000" dirty="0"/>
               <a:t>- Claude guesses -&gt; inconsistent</a:t>
             </a:r>
           </a:p>
@@ -21661,6 +21960,7 @@
               </a:defRPr>
             </a:pPr>
             <a:r>
+              <a:rPr sz="1000" dirty="0"/>
               <a:t>- High false positive rate</a:t>
             </a:r>
           </a:p>
@@ -21677,6 +21977,7 @@
               </a:defRPr>
             </a:pPr>
             <a:r>
+              <a:rPr sz="1000" dirty="0"/>
               <a:t>- Different results each run!</a:t>
             </a:r>
           </a:p>
@@ -21724,6 +22025,7 @@
           <a:lstStyle/>
           <a:p>
             <a:pPr algn="ctr"/>
+            <a:endParaRPr/>
           </a:p>
         </p:txBody>
       </p:sp>
@@ -21772,7 +22074,7 @@
         <p:spPr>
           <a:xfrm>
             <a:off x="6492240" y="2194560"/>
-            <a:ext cx="4846320" cy="2194560"/>
+            <a:ext cx="4846320" cy="2208297"/>
           </a:xfrm>
           <a:prstGeom prst="rect">
             <a:avLst/>
@@ -21797,7 +22099,31 @@
               </a:defRPr>
             </a:pPr>
             <a:r>
-              <a:t>"Classify each issue as:</a:t>
+              <a:rPr sz="1000" dirty="0">
+                <a:solidFill>
+                  <a:srgbClr val="2ECC71"/>
+                </a:solidFill>
+                <a:latin typeface="Courier New"/>
+              </a:rPr>
+              <a:t>"</a:t>
+            </a:r>
+            <a:r>
+              <a:rPr sz="1000" b="1" dirty="0">
+                <a:solidFill>
+                  <a:srgbClr val="2ECC71"/>
+                </a:solidFill>
+                <a:latin typeface="Courier New"/>
+              </a:rPr>
+              <a:t>Classify each issue as</a:t>
+            </a:r>
+            <a:r>
+              <a:rPr sz="1000" dirty="0">
+                <a:solidFill>
+                  <a:srgbClr val="2ECC71"/>
+                </a:solidFill>
+                <a:latin typeface="Courier New"/>
+              </a:rPr>
+              <a:t>:</a:t>
             </a:r>
           </a:p>
           <a:p>
@@ -21813,6 +22139,7 @@
               </a:defRPr>
             </a:pPr>
             <a:r>
+              <a:rPr sz="1000" dirty="0"/>
               <a:t> SECURITY | PERFORMANCE | STYLE</a:t>
             </a:r>
           </a:p>
@@ -21829,6 +22156,7 @@
               </a:defRPr>
             </a:pPr>
             <a:r>
+              <a:rPr sz="1000" dirty="0"/>
               <a:t> Severity: CRITICAL if data loss</a:t>
             </a:r>
           </a:p>
@@ -21845,6 +22173,7 @@
               </a:defRPr>
             </a:pPr>
             <a:r>
+              <a:rPr sz="1000" dirty="0"/>
               <a:t> or injection. HIGH if feature</a:t>
             </a:r>
           </a:p>
@@ -21861,6 +22190,7 @@
               </a:defRPr>
             </a:pPr>
             <a:r>
+              <a:rPr sz="1000" dirty="0"/>
               <a:t> breaks. MEDIUM if UX degrades."</a:t>
             </a:r>
           </a:p>
@@ -21876,6 +22206,7 @@
                 <a:latin typeface="Courier New"/>
               </a:defRPr>
             </a:pPr>
+            <a:endParaRPr sz="1000" dirty="0"/>
           </a:p>
           <a:p>
             <a:pPr>
@@ -21890,6 +22221,7 @@
               </a:defRPr>
             </a:pPr>
             <a:r>
+              <a:rPr sz="1000" dirty="0"/>
               <a:t>Benefits:</a:t>
             </a:r>
           </a:p>
@@ -21906,6 +22238,7 @@
               </a:defRPr>
             </a:pPr>
             <a:r>
+              <a:rPr sz="1000" dirty="0"/>
               <a:t>- Clear categories = consistent</a:t>
             </a:r>
           </a:p>
@@ -21922,6 +22255,7 @@
               </a:defRPr>
             </a:pPr>
             <a:r>
+              <a:rPr sz="1000" dirty="0"/>
               <a:t>- Defined severity = actionable</a:t>
             </a:r>
           </a:p>
@@ -21938,6 +22272,7 @@
               </a:defRPr>
             </a:pPr>
             <a:r>
+              <a:rPr sz="1000" dirty="0"/>
               <a:t>- Reproducible across runs!</a:t>
             </a:r>
           </a:p>
@@ -21985,6 +22320,7 @@
           <a:lstStyle/>
           <a:p>
             <a:pPr algn="ctr"/>
+            <a:endParaRPr/>
           </a:p>
         </p:txBody>
       </p:sp>
@@ -22058,6 +22394,7 @@
               </a:defRPr>
             </a:pPr>
             <a:r>
+              <a:rPr dirty="0"/>
               <a:t>Vague: 'Grade these essays fairly.' -- Every teacher grades differently. No consistency!</a:t>
             </a:r>
           </a:p>
@@ -22074,6 +22411,7 @@
               </a:defRPr>
             </a:pPr>
             <a:r>
+              <a:rPr dirty="0"/>
               <a:t>Explicit: 'Use this rubric: Thesis (20pts), Evidence (30pts), Grammar (20pts), Structure (30pts)'.</a:t>
             </a:r>
           </a:p>
@@ -22090,6 +22428,7 @@
               </a:defRPr>
             </a:pPr>
             <a:r>
+              <a:rPr dirty="0"/>
               <a:t>With a rubric, ANY teacher produces consistent grades. Explicit prompts are your rubric for Claude!</a:t>
             </a:r>
           </a:p>
@@ -22105,6 +22444,7 @@
                 <a:latin typeface="Calibri"/>
               </a:defRPr>
             </a:pPr>
+            <a:endParaRPr dirty="0"/>
           </a:p>
           <a:p>
             <a:pPr>
@@ -22119,6 +22459,7 @@
               </a:defRPr>
             </a:pPr>
             <a:r>
+              <a:rPr dirty="0"/>
               <a:t>Reducing false positives = iterating on your rubric. Run it, check results, tighten the criteria.</a:t>
             </a:r>
           </a:p>
@@ -22133,7 +22474,7 @@
 </file>
 
 <file path=ppt/slides/slide6.xml><?xml version="1.0" encoding="utf-8"?>
-<p:sld xmlns:a="http://schemas.openxmlformats.org/drawingml/2006/main" xmlns:p="http://schemas.openxmlformats.org/presentationml/2006/main" xmlns:r="http://schemas.openxmlformats.org/officeDocument/2006/relationships">
+<p:sld xmlns:a="http://schemas.openxmlformats.org/drawingml/2006/main" xmlns:r="http://schemas.openxmlformats.org/officeDocument/2006/relationships" xmlns:p="http://schemas.openxmlformats.org/presentationml/2006/main">
   <p:cSld>
     <p:bg>
       <p:bgPr>
@@ -22149,7 +22490,14 @@
         <p:cNvGrpSpPr/>
         <p:nvPr/>
       </p:nvGrpSpPr>
-      <p:grpSpPr/>
+      <p:grpSpPr>
+        <a:xfrm>
+          <a:off x="0" y="0"/>
+          <a:ext cx="0" cy="0"/>
+          <a:chOff x="0" y="0"/>
+          <a:chExt cx="0" cy="0"/>
+        </a:xfrm>
+      </p:grpSpPr>
       <p:sp>
         <p:nvSpPr>
           <p:cNvPr id="2" name="Rounded Rectangle 1"/>
@@ -22190,6 +22538,7 @@
           <a:lstStyle/>
           <a:p>
             <a:pPr algn="ctr"/>
+            <a:endParaRPr/>
           </a:p>
         </p:txBody>
       </p:sp>
@@ -22341,6 +22690,7 @@
           <a:lstStyle/>
           <a:p>
             <a:pPr algn="ctr"/>
+            <a:endParaRPr/>
           </a:p>
         </p:txBody>
       </p:sp>
@@ -22353,7 +22703,7 @@
         <p:spPr>
           <a:xfrm>
             <a:off x="731520" y="1828800"/>
-            <a:ext cx="5577840" cy="3931920"/>
+            <a:ext cx="5577840" cy="3952364"/>
           </a:xfrm>
           <a:prstGeom prst="rect">
             <a:avLst/>
@@ -22378,6 +22728,7 @@
               </a:defRPr>
             </a:pPr>
             <a:r>
+              <a:rPr sz="1000" dirty="0"/>
               <a:t># Prompt with explicit severity tiers</a:t>
             </a:r>
           </a:p>
@@ -22393,6 +22744,14 @@
                 <a:latin typeface="Courier New"/>
               </a:defRPr>
             </a:pPr>
+            <a:r>
+              <a:rPr sz="1000" dirty="0" err="1"/>
+              <a:t>system_prompt</a:t>
+            </a:r>
+            <a:r>
+              <a:rPr sz="1000" dirty="0"/>
+              <a:t> = """</a:t>
+            </a:r>
           </a:p>
           <a:p>
             <a:pPr>
@@ -22407,7 +22766,8 @@
               </a:defRPr>
             </a:pPr>
             <a:r>
-              <a:t>system_prompt = """</a:t>
+              <a:rPr sz="1000" dirty="0"/>
+              <a:t>Classify each code issue found.</a:t>
             </a:r>
           </a:p>
           <a:p>
@@ -22422,296 +22782,251 @@
                 <a:latin typeface="Courier New"/>
               </a:defRPr>
             </a:pPr>
-            <a:r>
-              <a:t>Classify each code issue found.</a:t>
-            </a:r>
+            <a:endParaRPr sz="1000" dirty="0"/>
           </a:p>
           <a:p>
             <a:pPr>
               <a:spcAft>
                 <a:spcPts val="480"/>
               </a:spcAft>
+              <a:defRPr sz="1200" b="1">
+                <a:solidFill>
+                  <a:srgbClr val="2ECC71"/>
+                </a:solidFill>
+                <a:latin typeface="Courier New"/>
+              </a:defRPr>
+            </a:pPr>
+            <a:r>
+              <a:rPr sz="1000" dirty="0"/>
+              <a:t>SEVERITY DEFINITIONS:</a:t>
+            </a:r>
+          </a:p>
+          <a:p>
+            <a:pPr>
+              <a:spcAft>
+                <a:spcPts val="480"/>
+              </a:spcAft>
+              <a:defRPr sz="1200" b="1">
+                <a:solidFill>
+                  <a:srgbClr val="E74C3C"/>
+                </a:solidFill>
+                <a:latin typeface="Courier New"/>
+              </a:defRPr>
+            </a:pPr>
+            <a:r>
+              <a:rPr sz="1000" dirty="0"/>
+              <a:t>CRITICAL:</a:t>
+            </a:r>
+          </a:p>
+          <a:p>
+            <a:pPr>
+              <a:spcAft>
+                <a:spcPts val="480"/>
+              </a:spcAft>
               <a:defRPr sz="1200" b="0">
                 <a:solidFill>
+                  <a:srgbClr val="F0C674"/>
+                </a:solidFill>
+                <a:latin typeface="Courier New"/>
+              </a:defRPr>
+            </a:pPr>
+            <a:r>
+              <a:rPr sz="1000" dirty="0"/>
+              <a:t>  - SQL injection or XSS</a:t>
+            </a:r>
+          </a:p>
+          <a:p>
+            <a:pPr>
+              <a:spcAft>
+                <a:spcPts val="480"/>
+              </a:spcAft>
+              <a:defRPr sz="1200" b="0">
+                <a:solidFill>
+                  <a:srgbClr val="F0C674"/>
+                </a:solidFill>
+                <a:latin typeface="Courier New"/>
+              </a:defRPr>
+            </a:pPr>
+            <a:r>
+              <a:rPr sz="1000" dirty="0"/>
+              <a:t>  - Hardcoded secrets/passwords</a:t>
+            </a:r>
+          </a:p>
+          <a:p>
+            <a:pPr>
+              <a:spcAft>
+                <a:spcPts val="480"/>
+              </a:spcAft>
+              <a:defRPr sz="1200" b="0">
+                <a:solidFill>
+                  <a:srgbClr val="F0C674"/>
+                </a:solidFill>
+                <a:latin typeface="Courier New"/>
+              </a:defRPr>
+            </a:pPr>
+            <a:r>
+              <a:rPr sz="1000" dirty="0"/>
+              <a:t>  - Data loss or corruption risk</a:t>
+            </a:r>
+          </a:p>
+          <a:p>
+            <a:pPr>
+              <a:spcAft>
+                <a:spcPts val="480"/>
+              </a:spcAft>
+              <a:defRPr sz="1200" b="1">
+                <a:solidFill>
+                  <a:srgbClr val="E67E22"/>
+                </a:solidFill>
+                <a:latin typeface="Courier New"/>
+              </a:defRPr>
+            </a:pPr>
+            <a:r>
+              <a:rPr sz="1000" dirty="0"/>
+              <a:t>HIGH:</a:t>
+            </a:r>
+          </a:p>
+          <a:p>
+            <a:pPr>
+              <a:spcAft>
+                <a:spcPts val="480"/>
+              </a:spcAft>
+              <a:defRPr sz="1200" b="0">
+                <a:solidFill>
+                  <a:srgbClr val="F0C674"/>
+                </a:solidFill>
+                <a:latin typeface="Courier New"/>
+              </a:defRPr>
+            </a:pPr>
+            <a:r>
+              <a:rPr sz="1000" dirty="0"/>
+              <a:t>  - Feature completely broken</a:t>
+            </a:r>
+          </a:p>
+          <a:p>
+            <a:pPr>
+              <a:spcAft>
+                <a:spcPts val="480"/>
+              </a:spcAft>
+              <a:defRPr sz="1200" b="0">
+                <a:solidFill>
+                  <a:srgbClr val="F0C674"/>
+                </a:solidFill>
+                <a:latin typeface="Courier New"/>
+              </a:defRPr>
+            </a:pPr>
+            <a:r>
+              <a:rPr sz="1000" dirty="0"/>
+              <a:t>  - </a:t>
+            </a:r>
+            <a:r>
+              <a:rPr lang="en-US" sz="1000" dirty="0"/>
+              <a:t>A</a:t>
+            </a:r>
+            <a:r>
+              <a:rPr sz="1000" dirty="0"/>
+              <a:t>uthentication bypass</a:t>
+            </a:r>
+          </a:p>
+          <a:p>
+            <a:pPr>
+              <a:spcAft>
+                <a:spcPts val="480"/>
+              </a:spcAft>
+              <a:defRPr sz="1200" b="1">
+                <a:solidFill>
+                  <a:srgbClr val="3498DB"/>
+                </a:solidFill>
+                <a:latin typeface="Courier New"/>
+              </a:defRPr>
+            </a:pPr>
+            <a:r>
+              <a:rPr sz="1000" dirty="0"/>
+              <a:t>MEDIUM:</a:t>
+            </a:r>
+          </a:p>
+          <a:p>
+            <a:pPr>
+              <a:spcAft>
+                <a:spcPts val="480"/>
+              </a:spcAft>
+              <a:defRPr sz="1200" b="0">
+                <a:solidFill>
+                  <a:srgbClr val="F0C674"/>
+                </a:solidFill>
+                <a:latin typeface="Courier New"/>
+              </a:defRPr>
+            </a:pPr>
+            <a:r>
+              <a:rPr sz="1000" dirty="0"/>
+              <a:t>  - Degraded user experience</a:t>
+            </a:r>
+          </a:p>
+          <a:p>
+            <a:pPr>
+              <a:spcAft>
+                <a:spcPts val="480"/>
+              </a:spcAft>
+              <a:defRPr sz="1200" b="0">
+                <a:solidFill>
+                  <a:srgbClr val="F0C674"/>
+                </a:solidFill>
+                <a:latin typeface="Courier New"/>
+              </a:defRPr>
+            </a:pPr>
+            <a:r>
+              <a:rPr sz="1000" dirty="0"/>
+              <a:t>  - Missing error handling</a:t>
+            </a:r>
+          </a:p>
+          <a:p>
+            <a:pPr>
+              <a:spcAft>
+                <a:spcPts val="480"/>
+              </a:spcAft>
+              <a:defRPr sz="1200" b="1">
+                <a:solidFill>
+                  <a:srgbClr val="2ECC71"/>
+                </a:solidFill>
+                <a:latin typeface="Courier New"/>
+              </a:defRPr>
+            </a:pPr>
+            <a:r>
+              <a:rPr sz="1000" dirty="0"/>
+              <a:t>LOW:</a:t>
+            </a:r>
+          </a:p>
+          <a:p>
+            <a:pPr>
+              <a:spcAft>
+                <a:spcPts val="480"/>
+              </a:spcAft>
+              <a:defRPr sz="1200" b="0">
+                <a:solidFill>
+                  <a:srgbClr val="F0C674"/>
+                </a:solidFill>
+                <a:latin typeface="Courier New"/>
+              </a:defRPr>
+            </a:pPr>
+            <a:r>
+              <a:rPr sz="1000" dirty="0"/>
+              <a:t>  - Code style / naming issues</a:t>
+            </a:r>
+          </a:p>
+          <a:p>
+            <a:pPr>
+              <a:spcAft>
+                <a:spcPts val="480"/>
+              </a:spcAft>
+              <a:defRPr sz="1200" b="0">
+                <a:solidFill>
                   <a:srgbClr val="FFFFFF"/>
                 </a:solidFill>
                 <a:latin typeface="Courier New"/>
               </a:defRPr>
             </a:pPr>
-          </a:p>
-          <a:p>
-            <a:pPr>
-              <a:spcAft>
-                <a:spcPts val="480"/>
-              </a:spcAft>
-              <a:defRPr sz="1200" b="1">
-                <a:solidFill>
-                  <a:srgbClr val="2ECC71"/>
-                </a:solidFill>
-                <a:latin typeface="Courier New"/>
-              </a:defRPr>
-            </a:pPr>
-            <a:r>
-              <a:t>SEVERITY DEFINITIONS:</a:t>
-            </a:r>
-          </a:p>
-          <a:p>
-            <a:pPr>
-              <a:spcAft>
-                <a:spcPts val="480"/>
-              </a:spcAft>
-              <a:defRPr sz="1200" b="0">
-                <a:solidFill>
-                  <a:srgbClr val="FFFFFF"/>
-                </a:solidFill>
-                <a:latin typeface="Courier New"/>
-              </a:defRPr>
-            </a:pPr>
-          </a:p>
-          <a:p>
-            <a:pPr>
-              <a:spcAft>
-                <a:spcPts val="480"/>
-              </a:spcAft>
-              <a:defRPr sz="1200" b="1">
-                <a:solidFill>
-                  <a:srgbClr val="E74C3C"/>
-                </a:solidFill>
-                <a:latin typeface="Courier New"/>
-              </a:defRPr>
-            </a:pPr>
-            <a:r>
-              <a:t>CRITICAL:</a:t>
-            </a:r>
-          </a:p>
-          <a:p>
-            <a:pPr>
-              <a:spcAft>
-                <a:spcPts val="480"/>
-              </a:spcAft>
-              <a:defRPr sz="1200" b="0">
-                <a:solidFill>
-                  <a:srgbClr val="F0C674"/>
-                </a:solidFill>
-                <a:latin typeface="Courier New"/>
-              </a:defRPr>
-            </a:pPr>
-            <a:r>
-              <a:t>  - SQL injection or XSS</a:t>
-            </a:r>
-          </a:p>
-          <a:p>
-            <a:pPr>
-              <a:spcAft>
-                <a:spcPts val="480"/>
-              </a:spcAft>
-              <a:defRPr sz="1200" b="0">
-                <a:solidFill>
-                  <a:srgbClr val="F0C674"/>
-                </a:solidFill>
-                <a:latin typeface="Courier New"/>
-              </a:defRPr>
-            </a:pPr>
-            <a:r>
-              <a:t>  - Hardcoded secrets/passwords</a:t>
-            </a:r>
-          </a:p>
-          <a:p>
-            <a:pPr>
-              <a:spcAft>
-                <a:spcPts val="480"/>
-              </a:spcAft>
-              <a:defRPr sz="1200" b="0">
-                <a:solidFill>
-                  <a:srgbClr val="F0C674"/>
-                </a:solidFill>
-                <a:latin typeface="Courier New"/>
-              </a:defRPr>
-            </a:pPr>
-            <a:r>
-              <a:t>  - Data loss or corruption risk</a:t>
-            </a:r>
-          </a:p>
-          <a:p>
-            <a:pPr>
-              <a:spcAft>
-                <a:spcPts val="480"/>
-              </a:spcAft>
-              <a:defRPr sz="1200" b="0">
-                <a:solidFill>
-                  <a:srgbClr val="FFFFFF"/>
-                </a:solidFill>
-                <a:latin typeface="Courier New"/>
-              </a:defRPr>
-            </a:pPr>
-          </a:p>
-          <a:p>
-            <a:pPr>
-              <a:spcAft>
-                <a:spcPts val="480"/>
-              </a:spcAft>
-              <a:defRPr sz="1200" b="1">
-                <a:solidFill>
-                  <a:srgbClr val="E67E22"/>
-                </a:solidFill>
-                <a:latin typeface="Courier New"/>
-              </a:defRPr>
-            </a:pPr>
-            <a:r>
-              <a:t>HIGH:</a:t>
-            </a:r>
-          </a:p>
-          <a:p>
-            <a:pPr>
-              <a:spcAft>
-                <a:spcPts val="480"/>
-              </a:spcAft>
-              <a:defRPr sz="1200" b="0">
-                <a:solidFill>
-                  <a:srgbClr val="F0C674"/>
-                </a:solidFill>
-                <a:latin typeface="Courier New"/>
-              </a:defRPr>
-            </a:pPr>
-            <a:r>
-              <a:t>  - Feature completely broken</a:t>
-            </a:r>
-          </a:p>
-          <a:p>
-            <a:pPr>
-              <a:spcAft>
-                <a:spcPts val="480"/>
-              </a:spcAft>
-              <a:defRPr sz="1200" b="0">
-                <a:solidFill>
-                  <a:srgbClr val="F0C674"/>
-                </a:solidFill>
-                <a:latin typeface="Courier New"/>
-              </a:defRPr>
-            </a:pPr>
-            <a:r>
-              <a:t>  - Authentication bypass</a:t>
-            </a:r>
-          </a:p>
-          <a:p>
-            <a:pPr>
-              <a:spcAft>
-                <a:spcPts val="480"/>
-              </a:spcAft>
-              <a:defRPr sz="1200" b="0">
-                <a:solidFill>
-                  <a:srgbClr val="FFFFFF"/>
-                </a:solidFill>
-                <a:latin typeface="Courier New"/>
-              </a:defRPr>
-            </a:pPr>
-          </a:p>
-          <a:p>
-            <a:pPr>
-              <a:spcAft>
-                <a:spcPts val="480"/>
-              </a:spcAft>
-              <a:defRPr sz="1200" b="1">
-                <a:solidFill>
-                  <a:srgbClr val="3498DB"/>
-                </a:solidFill>
-                <a:latin typeface="Courier New"/>
-              </a:defRPr>
-            </a:pPr>
-            <a:r>
-              <a:t>MEDIUM:</a:t>
-            </a:r>
-          </a:p>
-          <a:p>
-            <a:pPr>
-              <a:spcAft>
-                <a:spcPts val="480"/>
-              </a:spcAft>
-              <a:defRPr sz="1200" b="0">
-                <a:solidFill>
-                  <a:srgbClr val="F0C674"/>
-                </a:solidFill>
-                <a:latin typeface="Courier New"/>
-              </a:defRPr>
-            </a:pPr>
-            <a:r>
-              <a:t>  - Degraded user experience</a:t>
-            </a:r>
-          </a:p>
-          <a:p>
-            <a:pPr>
-              <a:spcAft>
-                <a:spcPts val="480"/>
-              </a:spcAft>
-              <a:defRPr sz="1200" b="0">
-                <a:solidFill>
-                  <a:srgbClr val="F0C674"/>
-                </a:solidFill>
-                <a:latin typeface="Courier New"/>
-              </a:defRPr>
-            </a:pPr>
-            <a:r>
-              <a:t>  - Missing error handling</a:t>
-            </a:r>
-          </a:p>
-          <a:p>
-            <a:pPr>
-              <a:spcAft>
-                <a:spcPts val="480"/>
-              </a:spcAft>
-              <a:defRPr sz="1200" b="0">
-                <a:solidFill>
-                  <a:srgbClr val="FFFFFF"/>
-                </a:solidFill>
-                <a:latin typeface="Courier New"/>
-              </a:defRPr>
-            </a:pPr>
-          </a:p>
-          <a:p>
-            <a:pPr>
-              <a:spcAft>
-                <a:spcPts val="480"/>
-              </a:spcAft>
-              <a:defRPr sz="1200" b="1">
-                <a:solidFill>
-                  <a:srgbClr val="2ECC71"/>
-                </a:solidFill>
-                <a:latin typeface="Courier New"/>
-              </a:defRPr>
-            </a:pPr>
-            <a:r>
-              <a:t>LOW:</a:t>
-            </a:r>
-          </a:p>
-          <a:p>
-            <a:pPr>
-              <a:spcAft>
-                <a:spcPts val="480"/>
-              </a:spcAft>
-              <a:defRPr sz="1200" b="0">
-                <a:solidFill>
-                  <a:srgbClr val="F0C674"/>
-                </a:solidFill>
-                <a:latin typeface="Courier New"/>
-              </a:defRPr>
-            </a:pPr>
-            <a:r>
-              <a:t>  - Code style / naming issues</a:t>
-            </a:r>
-          </a:p>
-          <a:p>
-            <a:pPr>
-              <a:spcAft>
-                <a:spcPts val="480"/>
-              </a:spcAft>
-              <a:defRPr sz="1200" b="0">
-                <a:solidFill>
-                  <a:srgbClr val="FFFFFF"/>
-                </a:solidFill>
-                <a:latin typeface="Courier New"/>
-              </a:defRPr>
-            </a:pPr>
-            <a:r>
+            <a:r>
+              <a:rPr sz="1000" dirty="0"/>
               <a:t>"""</a:t>
             </a:r>
           </a:p>
@@ -22789,7 +23104,7 @@
           </a:fontRef>
         </p:style>
         <p:txBody>
-          <a:bodyPr rtlCol="0" anchor="ctr" wrap="square"/>
+          <a:bodyPr wrap="square" rtlCol="0" anchor="ctr"/>
           <a:lstStyle/>
           <a:p>
             <a:pPr algn="ctr">
@@ -22882,7 +23197,7 @@
           </a:fontRef>
         </p:style>
         <p:txBody>
-          <a:bodyPr rtlCol="0" anchor="ctr" wrap="square"/>
+          <a:bodyPr wrap="square" rtlCol="0" anchor="ctr"/>
           <a:lstStyle/>
           <a:p>
             <a:pPr algn="ctr">
@@ -22975,7 +23290,7 @@
           </a:fontRef>
         </p:style>
         <p:txBody>
-          <a:bodyPr rtlCol="0" anchor="ctr" wrap="square"/>
+          <a:bodyPr wrap="square" rtlCol="0" anchor="ctr"/>
           <a:lstStyle/>
           <a:p>
             <a:pPr algn="ctr">
@@ -23068,7 +23383,7 @@
           </a:fontRef>
         </p:style>
         <p:txBody>
-          <a:bodyPr rtlCol="0" anchor="ctr" wrap="square"/>
+          <a:bodyPr wrap="square" rtlCol="0" anchor="ctr"/>
           <a:lstStyle/>
           <a:p>
             <a:pPr algn="ctr">
@@ -23167,6 +23482,7 @@
           <a:lstStyle/>
           <a:p>
             <a:pPr algn="ctr"/>
+            <a:endParaRPr/>
           </a:p>
         </p:txBody>
       </p:sp>
@@ -23215,7 +23531,7 @@
 </file>
 
 <file path=ppt/slides/slide7.xml><?xml version="1.0" encoding="utf-8"?>
-<p:sld xmlns:a="http://schemas.openxmlformats.org/drawingml/2006/main" xmlns:p="http://schemas.openxmlformats.org/presentationml/2006/main" xmlns:r="http://schemas.openxmlformats.org/officeDocument/2006/relationships">
+<p:sld xmlns:a="http://schemas.openxmlformats.org/drawingml/2006/main" xmlns:r="http://schemas.openxmlformats.org/officeDocument/2006/relationships" xmlns:p="http://schemas.openxmlformats.org/presentationml/2006/main">
   <p:cSld>
     <p:bg>
       <p:bgPr>
@@ -23231,7 +23547,14 @@
         <p:cNvGrpSpPr/>
         <p:nvPr/>
       </p:nvGrpSpPr>
-      <p:grpSpPr/>
+      <p:grpSpPr>
+        <a:xfrm>
+          <a:off x="0" y="0"/>
+          <a:ext cx="0" cy="0"/>
+          <a:chOff x="0" y="0"/>
+          <a:chExt cx="0" cy="0"/>
+        </a:xfrm>
+      </p:grpSpPr>
       <p:sp>
         <p:nvSpPr>
           <p:cNvPr id="2" name="Oval 1"/>
@@ -23268,7 +23591,7 @@
           </a:fontRef>
         </p:style>
         <p:txBody>
-          <a:bodyPr rtlCol="0" anchor="ctr" wrap="square"/>
+          <a:bodyPr wrap="square" rtlCol="0" anchor="ctr"/>
           <a:lstStyle/>
           <a:p>
             <a:pPr algn="ctr">
@@ -23372,7 +23695,7 @@
 </file>
 
 <file path=ppt/slides/slide8.xml><?xml version="1.0" encoding="utf-8"?>
-<p:sld xmlns:a="http://schemas.openxmlformats.org/drawingml/2006/main" xmlns:p="http://schemas.openxmlformats.org/presentationml/2006/main" xmlns:r="http://schemas.openxmlformats.org/officeDocument/2006/relationships">
+<p:sld xmlns:a="http://schemas.openxmlformats.org/drawingml/2006/main" xmlns:r="http://schemas.openxmlformats.org/officeDocument/2006/relationships" xmlns:p="http://schemas.openxmlformats.org/presentationml/2006/main">
   <p:cSld>
     <p:bg>
       <p:bgPr>
@@ -23388,7 +23711,14 @@
         <p:cNvGrpSpPr/>
         <p:nvPr/>
       </p:nvGrpSpPr>
-      <p:grpSpPr/>
+      <p:grpSpPr>
+        <a:xfrm>
+          <a:off x="0" y="0"/>
+          <a:ext cx="0" cy="0"/>
+          <a:chOff x="0" y="0"/>
+          <a:chExt cx="0" cy="0"/>
+        </a:xfrm>
+      </p:grpSpPr>
       <p:sp>
         <p:nvSpPr>
           <p:cNvPr id="2" name="Rounded Rectangle 1"/>
@@ -23429,6 +23759,7 @@
           <a:lstStyle/>
           <a:p>
             <a:pPr algn="ctr"/>
+            <a:endParaRPr/>
           </a:p>
         </p:txBody>
       </p:sp>
@@ -23546,6 +23877,7 @@
           <a:lstStyle/>
           <a:p>
             <a:pPr algn="ctr"/>
+            <a:endParaRPr/>
           </a:p>
         </p:txBody>
       </p:sp>
@@ -23692,7 +24024,7 @@
           </a:fontRef>
         </p:style>
         <p:txBody>
-          <a:bodyPr rtlCol="0" anchor="ctr" wrap="square"/>
+          <a:bodyPr wrap="square" rtlCol="0" anchor="ctr"/>
           <a:lstStyle/>
           <a:p>
             <a:pPr algn="ctr">
@@ -23791,6 +24123,7 @@
           <a:lstStyle/>
           <a:p>
             <a:pPr algn="ctr"/>
+            <a:endParaRPr/>
           </a:p>
         </p:txBody>
       </p:sp>
@@ -23881,6 +24214,7 @@
           <a:lstStyle/>
           <a:p>
             <a:pPr algn="ctr"/>
+            <a:endParaRPr/>
           </a:p>
         </p:txBody>
       </p:sp>
@@ -23960,7 +24294,7 @@
           </a:fontRef>
         </p:style>
         <p:txBody>
-          <a:bodyPr rtlCol="0" anchor="ctr" wrap="square"/>
+          <a:bodyPr wrap="square" rtlCol="0" anchor="ctr"/>
           <a:lstStyle/>
           <a:p>
             <a:pPr algn="ctr">
@@ -24063,6 +24397,7 @@
           <a:lstStyle/>
           <a:p>
             <a:pPr algn="ctr"/>
+            <a:endParaRPr/>
           </a:p>
         </p:txBody>
       </p:sp>
@@ -24157,6 +24492,7 @@
           <a:lstStyle/>
           <a:p>
             <a:pPr algn="ctr"/>
+            <a:endParaRPr/>
           </a:p>
         </p:txBody>
       </p:sp>
@@ -24240,7 +24576,7 @@
           </a:fontRef>
         </p:style>
         <p:txBody>
-          <a:bodyPr rtlCol="0" anchor="ctr" wrap="square"/>
+          <a:bodyPr wrap="square" rtlCol="0" anchor="ctr"/>
           <a:lstStyle/>
           <a:p>
             <a:pPr algn="ctr">
@@ -24343,6 +24679,7 @@
           <a:lstStyle/>
           <a:p>
             <a:pPr algn="ctr"/>
+            <a:endParaRPr/>
           </a:p>
         </p:txBody>
       </p:sp>
@@ -24437,6 +24774,7 @@
           <a:lstStyle/>
           <a:p>
             <a:pPr algn="ctr"/>
+            <a:endParaRPr/>
           </a:p>
         </p:txBody>
       </p:sp>
@@ -24493,7 +24831,7 @@
 </file>
 
 <file path=ppt/slides/slide9.xml><?xml version="1.0" encoding="utf-8"?>
-<p:sld xmlns:a="http://schemas.openxmlformats.org/drawingml/2006/main" xmlns:p="http://schemas.openxmlformats.org/presentationml/2006/main" xmlns:r="http://schemas.openxmlformats.org/officeDocument/2006/relationships">
+<p:sld xmlns:a="http://schemas.openxmlformats.org/drawingml/2006/main" xmlns:r="http://schemas.openxmlformats.org/officeDocument/2006/relationships" xmlns:p="http://schemas.openxmlformats.org/presentationml/2006/main">
   <p:cSld>
     <p:bg>
       <p:bgPr>
@@ -24509,7 +24847,14 @@
         <p:cNvGrpSpPr/>
         <p:nvPr/>
       </p:nvGrpSpPr>
-      <p:grpSpPr/>
+      <p:grpSpPr>
+        <a:xfrm>
+          <a:off x="0" y="0"/>
+          <a:ext cx="0" cy="0"/>
+          <a:chOff x="0" y="0"/>
+          <a:chExt cx="0" cy="0"/>
+        </a:xfrm>
+      </p:grpSpPr>
       <p:sp>
         <p:nvSpPr>
           <p:cNvPr id="2" name="Rounded Rectangle 1"/>
@@ -24550,6 +24895,7 @@
           <a:lstStyle/>
           <a:p>
             <a:pPr algn="ctr"/>
+            <a:endParaRPr/>
           </a:p>
         </p:txBody>
       </p:sp>
@@ -24701,6 +25047,7 @@
           <a:lstStyle/>
           <a:p>
             <a:pPr algn="ctr"/>
+            <a:endParaRPr/>
           </a:p>
         </p:txBody>
       </p:sp>
@@ -24753,6 +25100,7 @@
                 <a:latin typeface="Courier New"/>
               </a:defRPr>
             </a:pPr>
+            <a:endParaRPr/>
           </a:p>
           <a:p>
             <a:pPr>
@@ -24862,6 +25210,7 @@
                 <a:latin typeface="Courier New"/>
               </a:defRPr>
             </a:pPr>
+            <a:endParaRPr/>
           </a:p>
           <a:p>
             <a:pPr>
@@ -24971,6 +25320,7 @@
                 <a:latin typeface="Courier New"/>
               </a:defRPr>
             </a:pPr>
+            <a:endParaRPr/>
           </a:p>
           <a:p>
             <a:pPr>
@@ -25080,6 +25430,7 @@
                 <a:latin typeface="Courier New"/>
               </a:defRPr>
             </a:pPr>
+            <a:endParaRPr/>
           </a:p>
           <a:p>
             <a:pPr>
@@ -25219,7 +25570,7 @@
           </a:fontRef>
         </p:style>
         <p:txBody>
-          <a:bodyPr rtlCol="0" anchor="ctr" wrap="square"/>
+          <a:bodyPr wrap="square" rtlCol="0" anchor="ctr"/>
           <a:lstStyle/>
           <a:p>
             <a:pPr algn="ctr">
@@ -25316,7 +25667,7 @@
           </a:fontRef>
         </p:style>
         <p:txBody>
-          <a:bodyPr rtlCol="0" anchor="ctr" wrap="square"/>
+          <a:bodyPr wrap="square" rtlCol="0" anchor="ctr"/>
           <a:lstStyle/>
           <a:p>
             <a:pPr algn="ctr">
@@ -25413,7 +25764,7 @@
           </a:fontRef>
         </p:style>
         <p:txBody>
-          <a:bodyPr rtlCol="0" anchor="ctr" wrap="square"/>
+          <a:bodyPr wrap="square" rtlCol="0" anchor="ctr"/>
           <a:lstStyle/>
           <a:p>
             <a:pPr algn="ctr">
@@ -25510,7 +25861,7 @@
           </a:fontRef>
         </p:style>
         <p:txBody>
-          <a:bodyPr rtlCol="0" anchor="ctr" wrap="square"/>
+          <a:bodyPr wrap="square" rtlCol="0" anchor="ctr"/>
           <a:lstStyle/>
           <a:p>
             <a:pPr algn="ctr">
@@ -25613,6 +25964,7 @@
           <a:lstStyle/>
           <a:p>
             <a:pPr algn="ctr"/>
+            <a:endParaRPr/>
           </a:p>
         </p:txBody>
       </p:sp>

</xml_diff>